<commit_message>
Add wrong/right example pictures to each ROBOTSS rule slide
Co-Authored-By: Claude Opus 5.5 <noreply@anthropic.com>
Claude-Session: https://claude.ai/code/session_01Cr6d8mb1XkHfhN1yyjHEjG
</commit_message>
<xml_diff>
--- a/APMT_Coaching_Pick_to_Rebin.pptx
+++ b/APMT_Coaching_Pick_to_Rebin.pptx
@@ -15,9 +15,10 @@
     <p:sldId id="263" r:id="rId9"/>
     <p:sldId id="264" r:id="rId10"/>
     <p:sldId id="265" r:id="rId11"/>
+    <p:sldId id="266" r:id="rId12"/>
   </p:sldIdLst>
   <p:notesMasterIdLst>
-    <p:notesMasterId r:id="rId12"/>
+    <p:notesMasterId r:id="rId13"/>
   </p:notesMasterIdLst>
   <p:sldSz cx="9144000" cy="5143500"/>
   <p:notesSz cx="5143500" cy="9144000"/>
@@ -116,7 +117,7 @@
   <p:extLst>
     <p:ext uri="{521415D9-36F7-43E2-AB2F-B90AF26B5E84}">
       <p14:sectionLst xmlns:p14="http://schemas.microsoft.com/office/powerpoint/2010/main">
-        <p14:section name="Intro" id="{a4cf69c1-9533-54a4-04bc-ec37e652a8ca}">
+        <p14:section name="Intro" id="{6ec9d610-bde1-2081-2570-3d95ebc5563d}">
           <p14:sldIdLst>
             <p14:sldId id="256"/>
             <p14:sldId id="257"/>
@@ -125,17 +126,18 @@
             <p14:sldId id="260"/>
           </p14:sldIdLst>
         </p14:section>
-        <p14:section name="Bin etiquette" id="{d9c96acf-ad0b-49b4-743f-b855e9bee4a5}">
+        <p14:section name="Bin etiquette" id="{23c4aaaf-a17a-4fab-f42c-432c5e8be6d2}">
           <p14:sldIdLst>
             <p14:sldId id="261"/>
             <p14:sldId id="262"/>
             <p14:sldId id="263"/>
+            <p14:sldId id="264"/>
           </p14:sldIdLst>
         </p14:section>
-        <p14:section name="Wrap-up" id="{abc51f49-8788-aa96-b46d-f967605300a3}">
+        <p14:section name="Wrap-up" id="{0b6a2282-2435-a14c-0307-0c31071c38d9}">
           <p14:sldIdLst>
-            <p14:sldId id="264"/>
             <p14:sldId id="265"/>
+            <p14:sldId id="266"/>
           </p14:sldIdLst>
         </p14:section>
       </p14:sectionLst>
@@ -630,7 +632,7 @@
           <a:p>
             <a:r>
               <a:rPr lang="en-US" dirty="0"/>
-              <a:t>Small fixes make a big impact. Thanks for watching, and thanks for looking after every bin, every time. If you have any questions, speak to your Process Guide, your Area Manager, or the ICQA team. And please take a second to rate this video.</a:t>
+              <a:t>So here's your pick checklist. Found an item that hasn't been picked yet? That's amnesty. Found one that's already been picked? That's outbound problem solve, not amnesty. And on every bin you touch, handle one item at a time and fix as you go. That keeps our wAPMT accurate, stops units falling, and gets our customers what they ordered.</a:t>
             </a:r>
             <a:endParaRPr lang="en-US" dirty="0"/>
           </a:p>
@@ -654,6 +656,94 @@
             <a:fld id="{F7021451-1387-4CA6-816F-3879F97B5CBC}" type="slidenum">
               <a:rPr lang="en-US"/>
               <a:t>10</a:t>
+            </a:fld>
+            <a:endParaRPr lang="en-US"/>
+          </a:p>
+        </p:txBody>
+      </p:sp>
+    </p:spTree>
+    <p:extLst>
+      <p:ext uri="{BB962C8B-B14F-4D97-AF65-F5344CB8AC3E}">
+        <p14:creationId xmlns:p14="http://schemas.microsoft.com/office/powerpoint/2010/main" val="1024086991"/>
+      </p:ext>
+    </p:extLst>
+  </p:cSld>
+  <p:clrMapOvr>
+    <a:masterClrMapping/>
+  </p:clrMapOvr>
+</p:notes>
+</file>
+
+<file path=ppt/notesSlides/notesSlide11.xml><?xml version="1.0" encoding="utf-8"?>
+<p:notes xmlns:a="http://schemas.openxmlformats.org/drawingml/2006/main" xmlns:r="http://schemas.openxmlformats.org/officeDocument/2006/relationships" xmlns:p="http://schemas.openxmlformats.org/presentationml/2006/main">
+  <p:cSld>
+    <p:spTree>
+      <p:nvGrpSpPr>
+        <p:cNvPr id="1" name=""/>
+        <p:cNvGrpSpPr/>
+        <p:nvPr/>
+      </p:nvGrpSpPr>
+      <p:grpSpPr>
+        <a:xfrm>
+          <a:off x="0" y="0"/>
+          <a:ext cx="0" cy="0"/>
+          <a:chOff x="0" y="0"/>
+          <a:chExt cx="0" cy="0"/>
+        </a:xfrm>
+      </p:grpSpPr>
+      <p:sp>
+        <p:nvSpPr>
+          <p:cNvPr id="2" name="Slide Image Placeholder 1"/>
+          <p:cNvSpPr>
+            <a:spLocks noGrp="1" noRot="1" noChangeAspect="1"/>
+          </p:cNvSpPr>
+          <p:nvPr>
+            <p:ph type="sldImg"/>
+          </p:nvPr>
+        </p:nvSpPr>
+        <p:spPr/>
+      </p:sp>
+      <p:sp>
+        <p:nvSpPr>
+          <p:cNvPr id="3" name="Notes Placeholder 2"/>
+          <p:cNvSpPr>
+            <a:spLocks noGrp="1"/>
+          </p:cNvSpPr>
+          <p:nvPr>
+            <p:ph type="body" idx="1"/>
+          </p:nvPr>
+        </p:nvSpPr>
+        <p:spPr/>
+        <p:txBody>
+          <a:bodyPr/>
+          <a:lstStyle/>
+          <a:p>
+            <a:r>
+              <a:rPr lang="en-US" dirty="0"/>
+              <a:t>Small fixes make a big impact. Thanks for watching, and thanks for looking after every bin, every time. If you have any questions, speak to your Process Guide, your Area Manager, or the ICQA team. And please take a second to rate this video.</a:t>
+            </a:r>
+            <a:endParaRPr lang="en-US" dirty="0"/>
+          </a:p>
+        </p:txBody>
+      </p:sp>
+      <p:sp>
+        <p:nvSpPr>
+          <p:cNvPr id="4" name="Slide Number Placeholder 3"/>
+          <p:cNvSpPr>
+            <a:spLocks noGrp="1"/>
+          </p:cNvSpPr>
+          <p:nvPr>
+            <p:ph type="sldNum" sz="quarter" idx="10"/>
+          </p:nvPr>
+        </p:nvSpPr>
+        <p:spPr/>
+        <p:txBody>
+          <a:bodyPr/>
+          <a:lstStyle/>
+          <a:p>
+            <a:fld id="{F7021451-1387-4CA6-816F-3879F97B5CBC}" type="slidenum">
+              <a:rPr lang="en-US"/>
+              <a:t>11</a:t>
             </a:fld>
             <a:endParaRPr lang="en-US"/>
           </a:p>
@@ -1246,7 +1336,7 @@
           <a:p>
             <a:r>
               <a:rPr lang="en-US" dirty="0"/>
-              <a:t>Second, fix as you go. Whenever your hands are in a bin, use the ROBOTSS rules to leave it better than you found it. No overhang: push anything sticking out fully back inside. Blocking: don't leave small items hidden behind big ones. Overstuffing: never force items back into a full bin. And stacking: keep everything below the retention bands. A few seconds from you stops units falling as the pod moves.</a:t>
+              <a:t>Second, fix as you go. Whenever your hands are in a bin, use the ROBOTSS rules to leave it better than you found it. No overhang: if anything is sticking out, push it fully back inside. Blocking: don't leave small items hidden behind big ones, and stand flat items upright so they can't slip between the bands.</a:t>
             </a:r>
             <a:endParaRPr lang="en-US" dirty="0"/>
           </a:p>
@@ -1334,7 +1424,7 @@
           <a:p>
             <a:r>
               <a:rPr lang="en-US" dirty="0"/>
-              <a:t>So here's your pick checklist. Found an item that hasn't been picked yet? That's amnesty. Found one that's already been picked? That's outbound problem solve, not amnesty. And on every bin you touch, handle one item at a time and fix as you go. That keeps our wAPMT accurate, stops units falling, and gets our customers what they ordered.</a:t>
+              <a:t>Overstuffing: never force items back into a full bin, because that's how products get damaged and spill out. And stacking: keep everything below the retention bands. A few seconds from you stops units falling as the pod moves.</a:t>
             </a:r>
             <a:endParaRPr lang="en-US" dirty="0"/>
           </a:p>
@@ -2188,6 +2278,420 @@
       </p:grpSpPr>
       <p:sp>
         <p:nvSpPr>
+          <p:cNvPr id="2" name="Text 0"/>
+          <p:cNvSpPr/>
+          <p:nvPr>
+            <p:ph idx="101" type="title" hasCustomPrompt="1"/>
+          </p:nvPr>
+        </p:nvSpPr>
+        <p:spPr>
+          <a:xfrm>
+            <a:off x="457200" y="640080"/>
+            <a:ext cx="5394960" cy="548640"/>
+          </a:xfrm>
+          <a:prstGeom prst="rect">
+            <a:avLst/>
+          </a:prstGeom>
+          <a:noFill/>
+          <a:ln/>
+        </p:spPr>
+        <p:txBody>
+          <a:bodyPr wrap="square" lIns="0" tIns="0" rIns="0" bIns="0" rtlCol="0" anchor="ctr"/>
+          <a:lstStyle/>
+          <a:p>
+            <a:pPr algn="l" indent="0" marL="0">
+              <a:buNone/>
+            </a:pPr>
+            <a:r>
+              <a:rPr lang="en-US" sz="2800" b="1" dirty="0">
+                <a:solidFill>
+                  <a:schemeClr val="tx1"/>
+                </a:solidFill>
+              </a:rPr>
+              <a:t>Your pick checklist</a:t>
+            </a:r>
+            <a:endParaRPr lang="en-US" sz="2800" dirty="0"/>
+          </a:p>
+        </p:txBody>
+      </p:sp>
+      <p:sp>
+        <p:nvSpPr>
+          <p:cNvPr id="3" name="Recap circle 1"/>
+          <p:cNvSpPr/>
+          <p:nvPr/>
+        </p:nvSpPr>
+        <p:spPr>
+          <a:xfrm>
+            <a:off x="868680" y="1371600"/>
+            <a:ext cx="868680" cy="868680"/>
+          </a:xfrm>
+          <a:prstGeom prst="ellipse">
+            <a:avLst/>
+          </a:prstGeom>
+          <a:solidFill>
+            <a:schemeClr val="accent1"/>
+          </a:solidFill>
+          <a:ln/>
+        </p:spPr>
+      </p:sp>
+      <p:pic>
+        <p:nvPicPr>
+          <p:cNvPr id="4" name="Recap icon 1" descr="preencoded.png">    </p:cNvPr>
+          <p:cNvPicPr>
+            <a:picLocks noChangeAspect="1"/>
+          </p:cNvPicPr>
+          <p:nvPr/>
+        </p:nvPicPr>
+        <p:blipFill>
+          <a:blip r:embed="rId1"/>
+          <a:stretch>
+            <a:fillRect/>
+          </a:stretch>
+        </p:blipFill>
+        <p:spPr>
+          <a:xfrm>
+            <a:off x="1088136" y="1591056"/>
+            <a:ext cx="429768" cy="429768"/>
+          </a:xfrm>
+          <a:prstGeom prst="rect">
+            <a:avLst/>
+          </a:prstGeom>
+        </p:spPr>
+      </p:pic>
+      <p:sp>
+        <p:nvSpPr>
+          <p:cNvPr id="5" name="Recap text 1"/>
+          <p:cNvSpPr txBox="1"/>
+          <p:nvPr/>
+        </p:nvSpPr>
+        <p:spPr>
+          <a:xfrm>
+            <a:off x="457200" y="2423160"/>
+            <a:ext cx="1691640" cy="1097280"/>
+          </a:xfrm>
+          <a:prstGeom prst="rect">
+            <a:avLst/>
+          </a:prstGeom>
+          <a:noFill/>
+          <a:ln/>
+        </p:spPr>
+        <p:txBody>
+          <a:bodyPr wrap="square" lIns="0" tIns="0" rIns="0" bIns="0" rtlCol="0" anchor="t"/>
+          <a:lstStyle/>
+          <a:p>
+            <a:pPr algn="ctr" indent="0" marL="0">
+              <a:buNone/>
+            </a:pPr>
+            <a:r>
+              <a:rPr lang="en-US" sz="1300" dirty="0">
+                <a:solidFill>
+                  <a:schemeClr val="accent4"/>
+                </a:solidFill>
+              </a:rPr>
+              <a:t>Not picked yet</a:t>
+            </a:r>
+            <a:endParaRPr lang="en-US" sz="1300" dirty="0"/>
+          </a:p>
+          <a:p>
+            <a:pPr algn="ctr" indent="0" marL="0">
+              <a:buNone/>
+            </a:pPr>
+            <a:r>
+              <a:rPr lang="en-US" sz="1700" b="1" dirty="0">
+                <a:solidFill>
+                  <a:schemeClr val="tx1"/>
+                </a:solidFill>
+              </a:rPr>
+              <a:t>Amnesty</a:t>
+            </a:r>
+            <a:endParaRPr lang="en-US" sz="1300" dirty="0"/>
+          </a:p>
+        </p:txBody>
+      </p:sp>
+      <p:sp>
+        <p:nvSpPr>
+          <p:cNvPr id="6" name="Recap circle 2"/>
+          <p:cNvSpPr/>
+          <p:nvPr/>
+        </p:nvSpPr>
+        <p:spPr>
+          <a:xfrm>
+            <a:off x="2697480" y="1371600"/>
+            <a:ext cx="868680" cy="868680"/>
+          </a:xfrm>
+          <a:prstGeom prst="ellipse">
+            <a:avLst/>
+          </a:prstGeom>
+          <a:solidFill>
+            <a:schemeClr val="accent1"/>
+          </a:solidFill>
+          <a:ln/>
+        </p:spPr>
+      </p:sp>
+      <p:pic>
+        <p:nvPicPr>
+          <p:cNvPr id="7" name="Recap icon 2" descr="preencoded.png">    </p:cNvPr>
+          <p:cNvPicPr>
+            <a:picLocks noChangeAspect="1"/>
+          </p:cNvPicPr>
+          <p:nvPr/>
+        </p:nvPicPr>
+        <p:blipFill>
+          <a:blip r:embed="rId2"/>
+          <a:stretch>
+            <a:fillRect/>
+          </a:stretch>
+        </p:blipFill>
+        <p:spPr>
+          <a:xfrm>
+            <a:off x="2916936" y="1591056"/>
+            <a:ext cx="429768" cy="429768"/>
+          </a:xfrm>
+          <a:prstGeom prst="rect">
+            <a:avLst/>
+          </a:prstGeom>
+        </p:spPr>
+      </p:pic>
+      <p:sp>
+        <p:nvSpPr>
+          <p:cNvPr id="8" name="Recap text 2"/>
+          <p:cNvSpPr txBox="1"/>
+          <p:nvPr/>
+        </p:nvSpPr>
+        <p:spPr>
+          <a:xfrm>
+            <a:off x="2286000" y="2423160"/>
+            <a:ext cx="1691640" cy="1097280"/>
+          </a:xfrm>
+          <a:prstGeom prst="rect">
+            <a:avLst/>
+          </a:prstGeom>
+          <a:noFill/>
+          <a:ln/>
+        </p:spPr>
+        <p:txBody>
+          <a:bodyPr wrap="square" lIns="0" tIns="0" rIns="0" bIns="0" rtlCol="0" anchor="t"/>
+          <a:lstStyle/>
+          <a:p>
+            <a:pPr algn="ctr" indent="0" marL="0">
+              <a:buNone/>
+            </a:pPr>
+            <a:r>
+              <a:rPr lang="en-US" sz="1300" dirty="0">
+                <a:solidFill>
+                  <a:schemeClr val="accent4"/>
+                </a:solidFill>
+              </a:rPr>
+              <a:t>Already picked</a:t>
+            </a:r>
+            <a:endParaRPr lang="en-US" sz="1300" dirty="0"/>
+          </a:p>
+          <a:p>
+            <a:pPr algn="ctr" indent="0" marL="0">
+              <a:buNone/>
+            </a:pPr>
+            <a:r>
+              <a:rPr lang="en-US" sz="1700" b="1" dirty="0">
+                <a:solidFill>
+                  <a:schemeClr val="tx1"/>
+                </a:solidFill>
+              </a:rPr>
+              <a:t>Outbound problem solve</a:t>
+            </a:r>
+            <a:endParaRPr lang="en-US" sz="1300" dirty="0"/>
+          </a:p>
+        </p:txBody>
+      </p:sp>
+      <p:sp>
+        <p:nvSpPr>
+          <p:cNvPr id="9" name="Recap circle 3"/>
+          <p:cNvSpPr/>
+          <p:nvPr/>
+        </p:nvSpPr>
+        <p:spPr>
+          <a:xfrm>
+            <a:off x="4526280" y="1371600"/>
+            <a:ext cx="868680" cy="868680"/>
+          </a:xfrm>
+          <a:prstGeom prst="ellipse">
+            <a:avLst/>
+          </a:prstGeom>
+          <a:solidFill>
+            <a:schemeClr val="accent1"/>
+          </a:solidFill>
+          <a:ln/>
+        </p:spPr>
+      </p:sp>
+      <p:pic>
+        <p:nvPicPr>
+          <p:cNvPr id="10" name="Recap icon 3" descr="preencoded.png">    </p:cNvPr>
+          <p:cNvPicPr>
+            <a:picLocks noChangeAspect="1"/>
+          </p:cNvPicPr>
+          <p:nvPr/>
+        </p:nvPicPr>
+        <p:blipFill>
+          <a:blip r:embed="rId3"/>
+          <a:stretch>
+            <a:fillRect/>
+          </a:stretch>
+        </p:blipFill>
+        <p:spPr>
+          <a:xfrm>
+            <a:off x="4745736" y="1591056"/>
+            <a:ext cx="429768" cy="429768"/>
+          </a:xfrm>
+          <a:prstGeom prst="rect">
+            <a:avLst/>
+          </a:prstGeom>
+        </p:spPr>
+      </p:pic>
+      <p:sp>
+        <p:nvSpPr>
+          <p:cNvPr id="11" name="Recap text 3"/>
+          <p:cNvSpPr txBox="1"/>
+          <p:nvPr/>
+        </p:nvSpPr>
+        <p:spPr>
+          <a:xfrm>
+            <a:off x="4114800" y="2423160"/>
+            <a:ext cx="1691640" cy="1097280"/>
+          </a:xfrm>
+          <a:prstGeom prst="rect">
+            <a:avLst/>
+          </a:prstGeom>
+          <a:noFill/>
+          <a:ln/>
+        </p:spPr>
+        <p:txBody>
+          <a:bodyPr wrap="square" lIns="0" tIns="0" rIns="0" bIns="0" rtlCol="0" anchor="t"/>
+          <a:lstStyle/>
+          <a:p>
+            <a:pPr algn="ctr" indent="0" marL="0">
+              <a:buNone/>
+            </a:pPr>
+            <a:r>
+              <a:rPr lang="en-US" sz="1300" dirty="0">
+                <a:solidFill>
+                  <a:schemeClr val="accent4"/>
+                </a:solidFill>
+              </a:rPr>
+              <a:t>Every bin you touch</a:t>
+            </a:r>
+            <a:endParaRPr lang="en-US" sz="1300" dirty="0"/>
+          </a:p>
+          <a:p>
+            <a:pPr algn="ctr" indent="0" marL="0">
+              <a:buNone/>
+            </a:pPr>
+            <a:r>
+              <a:rPr lang="en-US" sz="1700" b="1" dirty="0">
+                <a:solidFill>
+                  <a:schemeClr val="tx1"/>
+                </a:solidFill>
+              </a:rPr>
+              <a:t>One at a time, fix as you go</a:t>
+            </a:r>
+            <a:endParaRPr lang="en-US" sz="1300" dirty="0"/>
+          </a:p>
+        </p:txBody>
+      </p:sp>
+      <p:sp>
+        <p:nvSpPr>
+          <p:cNvPr id="12" name="Goal card"/>
+          <p:cNvSpPr/>
+          <p:nvPr/>
+        </p:nvSpPr>
+        <p:spPr>
+          <a:xfrm>
+            <a:off x="457200" y="3749040"/>
+            <a:ext cx="5394960" cy="777240"/>
+          </a:xfrm>
+          <a:prstGeom prst="roundRect">
+            <a:avLst>
+              <a:gd name="adj" fmla="val 11765"/>
+            </a:avLst>
+          </a:prstGeom>
+          <a:solidFill>
+            <a:schemeClr val="tx2"/>
+          </a:solidFill>
+          <a:ln/>
+        </p:spPr>
+      </p:sp>
+      <p:sp>
+        <p:nvSpPr>
+          <p:cNvPr id="13" name="Goal text"/>
+          <p:cNvSpPr txBox="1"/>
+          <p:nvPr/>
+        </p:nvSpPr>
+        <p:spPr>
+          <a:xfrm>
+            <a:off x="731520" y="3749040"/>
+            <a:ext cx="4846320" cy="777240"/>
+          </a:xfrm>
+          <a:prstGeom prst="rect">
+            <a:avLst/>
+          </a:prstGeom>
+          <a:noFill/>
+          <a:ln/>
+        </p:spPr>
+        <p:txBody>
+          <a:bodyPr wrap="square" lIns="0" tIns="0" rIns="0" bIns="0" rtlCol="0" anchor="ctr"/>
+          <a:lstStyle/>
+          <a:p>
+            <a:pPr indent="0" marL="0">
+              <a:buNone/>
+            </a:pPr>
+            <a:r>
+              <a:rPr lang="en-US" sz="1600" b="1" dirty="0">
+                <a:solidFill>
+                  <a:srgbClr val="9EDFF7"/>
+                </a:solidFill>
+              </a:rPr>
+              <a:t>Goal: </a:t>
+            </a:r>
+            <a:pPr indent="0" marL="0">
+              <a:buNone/>
+            </a:pPr>
+            <a:r>
+              <a:rPr lang="en-US" sz="1600" dirty="0">
+                <a:solidFill>
+                  <a:schemeClr val="bg1"/>
+                </a:solidFill>
+              </a:rPr>
+              <a:t>an accurate wAPMT, fewer units falling, happier customers.</a:t>
+            </a:r>
+            <a:endParaRPr lang="en-US" sz="1600" dirty="0"/>
+          </a:p>
+        </p:txBody>
+      </p:sp>
+    </p:spTree>
+  </p:cSld>
+  <p:clrMapOvr>
+    <a:masterClrMapping/>
+  </p:clrMapOvr>
+</p:sld>
+</file>
+
+<file path=ppt/slides/slide11.xml><?xml version="1.0" encoding="utf-8"?>
+<p:sld xmlns:a="http://schemas.openxmlformats.org/drawingml/2006/main" xmlns:r="http://schemas.openxmlformats.org/officeDocument/2006/relationships" xmlns:p="http://schemas.openxmlformats.org/presentationml/2006/main">
+  <p:cSld name="Slide 11">
+    <p:spTree>
+      <p:nvGrpSpPr>
+        <p:cNvPr id="1" name=""/>
+        <p:cNvGrpSpPr/>
+        <p:nvPr/>
+      </p:nvGrpSpPr>
+      <p:grpSpPr>
+        <a:xfrm>
+          <a:off x="0" y="0"/>
+          <a:ext cx="0" cy="0"/>
+          <a:chOff x="0" y="0"/>
+          <a:chExt cx="0" cy="0"/>
+        </a:xfrm>
+      </p:grpSpPr>
+      <p:sp>
+        <p:nvSpPr>
           <p:cNvPr id="2" name="Closing title"/>
           <p:cNvSpPr txBox="1"/>
           <p:nvPr/>
@@ -4673,7 +5177,7 @@
                   <a:schemeClr val="tx1"/>
                 </a:solidFill>
               </a:rPr>
-              <a:t>Fix as you go while you pick</a:t>
+              <a:t>Fix as you go: inside the bin</a:t>
             </a:r>
             <a:endParaRPr lang="en-US" sz="2800" dirty="0"/>
           </a:p>
@@ -4681,18 +5185,18 @@
       </p:sp>
       <p:sp>
         <p:nvSpPr>
-          <p:cNvPr id="3" name="Pick rule 1"/>
+          <p:cNvPr id="3" name="Rule card 1"/>
           <p:cNvSpPr/>
           <p:nvPr/>
         </p:nvSpPr>
         <p:spPr>
           <a:xfrm>
             <a:off x="457200" y="1325880"/>
-            <a:ext cx="2606040" cy="1463040"/>
+            <a:ext cx="2606040" cy="3246120"/>
           </a:xfrm>
           <a:prstGeom prst="roundRect">
             <a:avLst>
-              <a:gd name="adj" fmla="val 6250"/>
+              <a:gd name="adj" fmla="val 3509"/>
             </a:avLst>
           </a:prstGeom>
           <a:solidFill>
@@ -4703,14 +5207,14 @@
       </p:sp>
       <p:sp>
         <p:nvSpPr>
-          <p:cNvPr id="4" name="Pick badge 1"/>
+          <p:cNvPr id="4" name="Rule badge 1"/>
           <p:cNvSpPr/>
           <p:nvPr/>
         </p:nvSpPr>
         <p:spPr>
           <a:xfrm>
-            <a:off x="658368" y="1527048"/>
-            <a:ext cx="566928" cy="566928"/>
+            <a:off x="640080" y="1490472"/>
+            <a:ext cx="502920" cy="502920"/>
           </a:xfrm>
           <a:prstGeom prst="ellipse">
             <a:avLst/>
@@ -4723,14 +5227,14 @@
       </p:sp>
       <p:sp>
         <p:nvSpPr>
-          <p:cNvPr id="5" name="Pick letter 1"/>
+          <p:cNvPr id="5" name="Rule letter 1"/>
           <p:cNvSpPr txBox="1"/>
           <p:nvPr/>
         </p:nvSpPr>
         <p:spPr>
           <a:xfrm>
-            <a:off x="658368" y="1527048"/>
-            <a:ext cx="566928" cy="566928"/>
+            <a:off x="640080" y="1490472"/>
+            <a:ext cx="502920" cy="502920"/>
           </a:xfrm>
           <a:prstGeom prst="rect">
             <a:avLst/>
@@ -4746,7 +5250,7 @@
               <a:buNone/>
             </a:pPr>
             <a:r>
-              <a:rPr lang="en-US" sz="2400" b="1" dirty="0">
+              <a:rPr lang="en-US" sz="2200" b="1" dirty="0">
                 <a:solidFill>
                   <a:schemeClr val="accent1"/>
                 </a:solidFill>
@@ -4756,20 +5260,20 @@
               </a:rPr>
               <a:t>O</a:t>
             </a:r>
-            <a:endParaRPr lang="en-US" sz="2400" dirty="0"/>
-          </a:p>
-        </p:txBody>
-      </p:sp>
-      <p:sp>
-        <p:nvSpPr>
-          <p:cNvPr id="6" name="Pick rule name 1"/>
+            <a:endParaRPr lang="en-US" sz="2200" dirty="0"/>
+          </a:p>
+        </p:txBody>
+      </p:sp>
+      <p:sp>
+        <p:nvSpPr>
+          <p:cNvPr id="6" name="Rule name 1"/>
           <p:cNvSpPr txBox="1"/>
           <p:nvPr/>
         </p:nvSpPr>
         <p:spPr>
           <a:xfrm>
-            <a:off x="1371600" y="1527048"/>
-            <a:ext cx="1554480" cy="566928"/>
+            <a:off x="1280160" y="1490472"/>
+            <a:ext cx="1645920" cy="502920"/>
           </a:xfrm>
           <a:prstGeom prst="rect">
             <a:avLst/>
@@ -4796,16 +5300,40 @@
           </a:p>
         </p:txBody>
       </p:sp>
-      <p:sp>
-        <p:nvSpPr>
-          <p:cNvPr id="7" name="Pick rule text 1"/>
+      <p:pic>
+        <p:nvPicPr>
+          <p:cNvPr id="7" name="Rule picture 1" descr="No overhang: wrong and right example">    </p:cNvPr>
+          <p:cNvPicPr>
+            <a:picLocks noChangeAspect="1"/>
+          </p:cNvPicPr>
+          <p:nvPr/>
+        </p:nvPicPr>
+        <p:blipFill>
+          <a:blip r:embed="rId1"/>
+          <a:stretch>
+            <a:fillRect/>
+          </a:stretch>
+        </p:blipFill>
+        <p:spPr>
+          <a:xfrm>
+            <a:off x="640080" y="2143936"/>
+            <a:ext cx="2240280" cy="924208"/>
+          </a:xfrm>
+          <a:prstGeom prst="rect">
+            <a:avLst/>
+          </a:prstGeom>
+        </p:spPr>
+      </p:pic>
+      <p:sp>
+        <p:nvSpPr>
+          <p:cNvPr id="8" name="Rule detail 1"/>
           <p:cNvSpPr txBox="1"/>
           <p:nvPr/>
         </p:nvSpPr>
         <p:spPr>
           <a:xfrm>
-            <a:off x="658368" y="2194560"/>
-            <a:ext cx="2240280" cy="502920"/>
+            <a:off x="640080" y="3246120"/>
+            <a:ext cx="2286000" cy="1234440"/>
           </a:xfrm>
           <a:prstGeom prst="rect">
             <a:avLst/>
@@ -4817,8 +5345,12 @@
           <a:bodyPr wrap="square" lIns="0" tIns="0" rIns="0" bIns="0" rtlCol="0" anchor="t"/>
           <a:lstStyle/>
           <a:p>
-            <a:pPr indent="0" marL="0">
-              <a:buNone/>
+            <a:pPr marL="342900" indent="-342900">
+              <a:spcAft>
+                <a:spcPts val="400"/>
+              </a:spcAft>
+              <a:buSzPct val="100000"/>
+              <a:buChar char="•"/>
             </a:pPr>
             <a:r>
               <a:rPr lang="en-US" sz="1400" dirty="0">
@@ -4834,18 +5366,18 @@
       </p:sp>
       <p:sp>
         <p:nvSpPr>
-          <p:cNvPr id="8" name="Pick rule 2"/>
+          <p:cNvPr id="9" name="Rule card 2"/>
           <p:cNvSpPr/>
           <p:nvPr/>
         </p:nvSpPr>
         <p:spPr>
           <a:xfrm>
             <a:off x="3246120" y="1325880"/>
-            <a:ext cx="2606040" cy="1463040"/>
+            <a:ext cx="2606040" cy="3246120"/>
           </a:xfrm>
           <a:prstGeom prst="roundRect">
             <a:avLst>
-              <a:gd name="adj" fmla="val 6250"/>
+              <a:gd name="adj" fmla="val 3509"/>
             </a:avLst>
           </a:prstGeom>
           <a:solidFill>
@@ -4856,14 +5388,14 @@
       </p:sp>
       <p:sp>
         <p:nvSpPr>
-          <p:cNvPr id="9" name="Pick badge 2"/>
+          <p:cNvPr id="10" name="Rule badge 2"/>
           <p:cNvSpPr/>
           <p:nvPr/>
         </p:nvSpPr>
         <p:spPr>
           <a:xfrm>
-            <a:off x="3447288" y="1527048"/>
-            <a:ext cx="566928" cy="566928"/>
+            <a:off x="3429000" y="1490472"/>
+            <a:ext cx="502920" cy="502920"/>
           </a:xfrm>
           <a:prstGeom prst="ellipse">
             <a:avLst/>
@@ -4876,14 +5408,14 @@
       </p:sp>
       <p:sp>
         <p:nvSpPr>
-          <p:cNvPr id="10" name="Pick letter 2"/>
+          <p:cNvPr id="11" name="Rule letter 2"/>
           <p:cNvSpPr txBox="1"/>
           <p:nvPr/>
         </p:nvSpPr>
         <p:spPr>
           <a:xfrm>
-            <a:off x="3447288" y="1527048"/>
-            <a:ext cx="566928" cy="566928"/>
+            <a:off x="3429000" y="1490472"/>
+            <a:ext cx="502920" cy="502920"/>
           </a:xfrm>
           <a:prstGeom prst="rect">
             <a:avLst/>
@@ -4899,7 +5431,7 @@
               <a:buNone/>
             </a:pPr>
             <a:r>
-              <a:rPr lang="en-US" sz="2400" b="1" dirty="0">
+              <a:rPr lang="en-US" sz="2200" b="1" dirty="0">
                 <a:solidFill>
                   <a:schemeClr val="accent1"/>
                 </a:solidFill>
@@ -4909,20 +5441,20 @@
               </a:rPr>
               <a:t>B</a:t>
             </a:r>
-            <a:endParaRPr lang="en-US" sz="2400" dirty="0"/>
-          </a:p>
-        </p:txBody>
-      </p:sp>
-      <p:sp>
-        <p:nvSpPr>
-          <p:cNvPr id="11" name="Pick rule name 2"/>
+            <a:endParaRPr lang="en-US" sz="2200" dirty="0"/>
+          </a:p>
+        </p:txBody>
+      </p:sp>
+      <p:sp>
+        <p:nvSpPr>
+          <p:cNvPr id="12" name="Rule name 2"/>
           <p:cNvSpPr txBox="1"/>
           <p:nvPr/>
         </p:nvSpPr>
         <p:spPr>
           <a:xfrm>
-            <a:off x="4160520" y="1527048"/>
-            <a:ext cx="1554480" cy="566928"/>
+            <a:off x="4069080" y="1490472"/>
+            <a:ext cx="1645920" cy="502920"/>
           </a:xfrm>
           <a:prstGeom prst="rect">
             <a:avLst/>
@@ -4949,16 +5481,40 @@
           </a:p>
         </p:txBody>
       </p:sp>
-      <p:sp>
-        <p:nvSpPr>
-          <p:cNvPr id="12" name="Pick rule text 2"/>
+      <p:pic>
+        <p:nvPicPr>
+          <p:cNvPr id="13" name="Rule picture 2" descr="Blocking: wrong and right example">    </p:cNvPr>
+          <p:cNvPicPr>
+            <a:picLocks noChangeAspect="1"/>
+          </p:cNvPicPr>
+          <p:nvPr/>
+        </p:nvPicPr>
+        <p:blipFill>
+          <a:blip r:embed="rId2"/>
+          <a:stretch>
+            <a:fillRect/>
+          </a:stretch>
+        </p:blipFill>
+        <p:spPr>
+          <a:xfrm>
+            <a:off x="3429000" y="2136542"/>
+            <a:ext cx="2240280" cy="938995"/>
+          </a:xfrm>
+          <a:prstGeom prst="rect">
+            <a:avLst/>
+          </a:prstGeom>
+        </p:spPr>
+      </p:pic>
+      <p:sp>
+        <p:nvSpPr>
+          <p:cNvPr id="14" name="Rule detail 2"/>
           <p:cNvSpPr txBox="1"/>
           <p:nvPr/>
         </p:nvSpPr>
         <p:spPr>
           <a:xfrm>
-            <a:off x="3447288" y="2194560"/>
-            <a:ext cx="2240280" cy="502920"/>
+            <a:off x="3429000" y="3246120"/>
+            <a:ext cx="2286000" cy="1234440"/>
           </a:xfrm>
           <a:prstGeom prst="rect">
             <a:avLst/>
@@ -4970,8 +5526,12 @@
           <a:bodyPr wrap="square" lIns="0" tIns="0" rIns="0" bIns="0" rtlCol="0" anchor="t"/>
           <a:lstStyle/>
           <a:p>
-            <a:pPr indent="0" marL="0">
-              <a:buNone/>
+            <a:pPr marL="342900" indent="-342900">
+              <a:spcAft>
+                <a:spcPts val="400"/>
+              </a:spcAft>
+              <a:buSzPct val="100000"/>
+              <a:buChar char="•"/>
             </a:pPr>
             <a:r>
               <a:rPr lang="en-US" sz="1400" dirty="0">
@@ -4983,148 +5543,13 @@
             </a:r>
             <a:endParaRPr lang="en-US" sz="1400" dirty="0"/>
           </a:p>
-        </p:txBody>
-      </p:sp>
-      <p:sp>
-        <p:nvSpPr>
-          <p:cNvPr id="13" name="Pick rule 3"/>
-          <p:cNvSpPr/>
-          <p:nvPr/>
-        </p:nvSpPr>
-        <p:spPr>
-          <a:xfrm>
-            <a:off x="457200" y="2926080"/>
-            <a:ext cx="2606040" cy="1463040"/>
-          </a:xfrm>
-          <a:prstGeom prst="roundRect">
-            <a:avLst>
-              <a:gd name="adj" fmla="val 6250"/>
-            </a:avLst>
-          </a:prstGeom>
-          <a:solidFill>
-            <a:schemeClr val="bg1"/>
-          </a:solidFill>
-          <a:ln/>
-        </p:spPr>
-      </p:sp>
-      <p:sp>
-        <p:nvSpPr>
-          <p:cNvPr id="14" name="Pick badge 3"/>
-          <p:cNvSpPr/>
-          <p:nvPr/>
-        </p:nvSpPr>
-        <p:spPr>
-          <a:xfrm>
-            <a:off x="658368" y="3127248"/>
-            <a:ext cx="566928" cy="566928"/>
-          </a:xfrm>
-          <a:prstGeom prst="ellipse">
-            <a:avLst/>
-          </a:prstGeom>
-          <a:solidFill>
-            <a:schemeClr val="tx2"/>
-          </a:solidFill>
-          <a:ln/>
-        </p:spPr>
-      </p:sp>
-      <p:sp>
-        <p:nvSpPr>
-          <p:cNvPr id="15" name="Pick letter 3"/>
-          <p:cNvSpPr txBox="1"/>
-          <p:nvPr/>
-        </p:nvSpPr>
-        <p:spPr>
-          <a:xfrm>
-            <a:off x="658368" y="3127248"/>
-            <a:ext cx="566928" cy="566928"/>
-          </a:xfrm>
-          <a:prstGeom prst="rect">
-            <a:avLst/>
-          </a:prstGeom>
-          <a:noFill/>
-          <a:ln/>
-        </p:spPr>
-        <p:txBody>
-          <a:bodyPr wrap="square" lIns="0" tIns="0" rIns="0" bIns="0" rtlCol="0" anchor="ctr"/>
-          <a:lstStyle/>
-          <a:p>
-            <a:pPr algn="ctr" indent="0" marL="0">
-              <a:buNone/>
-            </a:pPr>
-            <a:r>
-              <a:rPr lang="en-US" sz="2400" b="1" dirty="0">
-                <a:solidFill>
-                  <a:schemeClr val="accent1"/>
-                </a:solidFill>
-                <a:latin typeface="Arial" pitchFamily="34" charset="0"/>
-                <a:ea typeface="Arial" pitchFamily="34" charset="-122"/>
-                <a:cs typeface="Arial" pitchFamily="34" charset="-120"/>
-              </a:rPr>
-              <a:t>O</a:t>
-            </a:r>
-            <a:endParaRPr lang="en-US" sz="2400" dirty="0"/>
-          </a:p>
-        </p:txBody>
-      </p:sp>
-      <p:sp>
-        <p:nvSpPr>
-          <p:cNvPr id="16" name="Pick rule name 3"/>
-          <p:cNvSpPr txBox="1"/>
-          <p:nvPr/>
-        </p:nvSpPr>
-        <p:spPr>
-          <a:xfrm>
-            <a:off x="1371600" y="3127248"/>
-            <a:ext cx="1554480" cy="566928"/>
-          </a:xfrm>
-          <a:prstGeom prst="rect">
-            <a:avLst/>
-          </a:prstGeom>
-          <a:noFill/>
-          <a:ln/>
-        </p:spPr>
-        <p:txBody>
-          <a:bodyPr wrap="square" lIns="0" tIns="0" rIns="0" bIns="0" rtlCol="0" anchor="ctr"/>
-          <a:lstStyle/>
-          <a:p>
-            <a:pPr indent="0" marL="0">
-              <a:buNone/>
-            </a:pPr>
-            <a:r>
-              <a:rPr lang="en-US" sz="1700" b="1" dirty="0">
-                <a:solidFill>
-                  <a:schemeClr val="tx1"/>
-                </a:solidFill>
-              </a:rPr>
-              <a:t>Overstuffing</a:t>
-            </a:r>
-            <a:endParaRPr lang="en-US" sz="1700" dirty="0"/>
-          </a:p>
-        </p:txBody>
-      </p:sp>
-      <p:sp>
-        <p:nvSpPr>
-          <p:cNvPr id="17" name="Pick rule text 3"/>
-          <p:cNvSpPr txBox="1"/>
-          <p:nvPr/>
-        </p:nvSpPr>
-        <p:spPr>
-          <a:xfrm>
-            <a:off x="658368" y="3794760"/>
-            <a:ext cx="2240280" cy="502920"/>
-          </a:xfrm>
-          <a:prstGeom prst="rect">
-            <a:avLst/>
-          </a:prstGeom>
-          <a:noFill/>
-          <a:ln/>
-        </p:spPr>
-        <p:txBody>
-          <a:bodyPr wrap="square" lIns="0" tIns="0" rIns="0" bIns="0" rtlCol="0" anchor="t"/>
-          <a:lstStyle/>
-          <a:p>
-            <a:pPr indent="0" marL="0">
-              <a:buNone/>
+          <a:p>
+            <a:pPr marL="342900" indent="-342900">
+              <a:spcAft>
+                <a:spcPts val="400"/>
+              </a:spcAft>
+              <a:buSzPct val="100000"/>
+              <a:buChar char="•"/>
             </a:pPr>
             <a:r>
               <a:rPr lang="en-US" sz="1400" dirty="0">
@@ -5132,160 +5557,7 @@
                   <a:schemeClr val="accent4"/>
                 </a:solidFill>
               </a:rPr>
-              <a:t>Never force items back into a full bin</a:t>
-            </a:r>
-            <a:endParaRPr lang="en-US" sz="1400" dirty="0"/>
-          </a:p>
-        </p:txBody>
-      </p:sp>
-      <p:sp>
-        <p:nvSpPr>
-          <p:cNvPr id="18" name="Pick rule 4"/>
-          <p:cNvSpPr/>
-          <p:nvPr/>
-        </p:nvSpPr>
-        <p:spPr>
-          <a:xfrm>
-            <a:off x="3246120" y="2926080"/>
-            <a:ext cx="2606040" cy="1463040"/>
-          </a:xfrm>
-          <a:prstGeom prst="roundRect">
-            <a:avLst>
-              <a:gd name="adj" fmla="val 6250"/>
-            </a:avLst>
-          </a:prstGeom>
-          <a:solidFill>
-            <a:schemeClr val="bg1"/>
-          </a:solidFill>
-          <a:ln/>
-        </p:spPr>
-      </p:sp>
-      <p:sp>
-        <p:nvSpPr>
-          <p:cNvPr id="19" name="Pick badge 4"/>
-          <p:cNvSpPr/>
-          <p:nvPr/>
-        </p:nvSpPr>
-        <p:spPr>
-          <a:xfrm>
-            <a:off x="3447288" y="3127248"/>
-            <a:ext cx="566928" cy="566928"/>
-          </a:xfrm>
-          <a:prstGeom prst="ellipse">
-            <a:avLst/>
-          </a:prstGeom>
-          <a:solidFill>
-            <a:schemeClr val="tx2"/>
-          </a:solidFill>
-          <a:ln/>
-        </p:spPr>
-      </p:sp>
-      <p:sp>
-        <p:nvSpPr>
-          <p:cNvPr id="20" name="Pick letter 4"/>
-          <p:cNvSpPr txBox="1"/>
-          <p:nvPr/>
-        </p:nvSpPr>
-        <p:spPr>
-          <a:xfrm>
-            <a:off x="3447288" y="3127248"/>
-            <a:ext cx="566928" cy="566928"/>
-          </a:xfrm>
-          <a:prstGeom prst="rect">
-            <a:avLst/>
-          </a:prstGeom>
-          <a:noFill/>
-          <a:ln/>
-        </p:spPr>
-        <p:txBody>
-          <a:bodyPr wrap="square" lIns="0" tIns="0" rIns="0" bIns="0" rtlCol="0" anchor="ctr"/>
-          <a:lstStyle/>
-          <a:p>
-            <a:pPr algn="ctr" indent="0" marL="0">
-              <a:buNone/>
-            </a:pPr>
-            <a:r>
-              <a:rPr lang="en-US" sz="2400" b="1" dirty="0">
-                <a:solidFill>
-                  <a:schemeClr val="accent1"/>
-                </a:solidFill>
-                <a:latin typeface="Arial" pitchFamily="34" charset="0"/>
-                <a:ea typeface="Arial" pitchFamily="34" charset="-122"/>
-                <a:cs typeface="Arial" pitchFamily="34" charset="-120"/>
-              </a:rPr>
-              <a:t>S</a:t>
-            </a:r>
-            <a:endParaRPr lang="en-US" sz="2400" dirty="0"/>
-          </a:p>
-        </p:txBody>
-      </p:sp>
-      <p:sp>
-        <p:nvSpPr>
-          <p:cNvPr id="21" name="Pick rule name 4"/>
-          <p:cNvSpPr txBox="1"/>
-          <p:nvPr/>
-        </p:nvSpPr>
-        <p:spPr>
-          <a:xfrm>
-            <a:off x="4160520" y="3127248"/>
-            <a:ext cx="1554480" cy="566928"/>
-          </a:xfrm>
-          <a:prstGeom prst="rect">
-            <a:avLst/>
-          </a:prstGeom>
-          <a:noFill/>
-          <a:ln/>
-        </p:spPr>
-        <p:txBody>
-          <a:bodyPr wrap="square" lIns="0" tIns="0" rIns="0" bIns="0" rtlCol="0" anchor="ctr"/>
-          <a:lstStyle/>
-          <a:p>
-            <a:pPr indent="0" marL="0">
-              <a:buNone/>
-            </a:pPr>
-            <a:r>
-              <a:rPr lang="en-US" sz="1700" b="1" dirty="0">
-                <a:solidFill>
-                  <a:schemeClr val="tx1"/>
-                </a:solidFill>
-              </a:rPr>
-              <a:t>Stacking</a:t>
-            </a:r>
-            <a:endParaRPr lang="en-US" sz="1700" dirty="0"/>
-          </a:p>
-        </p:txBody>
-      </p:sp>
-      <p:sp>
-        <p:nvSpPr>
-          <p:cNvPr id="22" name="Pick rule text 4"/>
-          <p:cNvSpPr txBox="1"/>
-          <p:nvPr/>
-        </p:nvSpPr>
-        <p:spPr>
-          <a:xfrm>
-            <a:off x="3447288" y="3794760"/>
-            <a:ext cx="2240280" cy="502920"/>
-          </a:xfrm>
-          <a:prstGeom prst="rect">
-            <a:avLst/>
-          </a:prstGeom>
-          <a:noFill/>
-          <a:ln/>
-        </p:spPr>
-        <p:txBody>
-          <a:bodyPr wrap="square" lIns="0" tIns="0" rIns="0" bIns="0" rtlCol="0" anchor="t"/>
-          <a:lstStyle/>
-          <a:p>
-            <a:pPr indent="0" marL="0">
-              <a:buNone/>
-            </a:pPr>
-            <a:r>
-              <a:rPr lang="en-US" sz="1400" dirty="0">
-                <a:solidFill>
-                  <a:schemeClr val="accent4"/>
-                </a:solidFill>
-              </a:rPr>
-              <a:t>Keep everything below the retention bands</a:t>
+              <a:t>Stand flat items upright</a:t>
             </a:r>
             <a:endParaRPr lang="en-US" sz="1400" dirty="0"/>
           </a:p>
@@ -5348,7 +5620,7 @@
                   <a:schemeClr val="tx1"/>
                 </a:solidFill>
               </a:rPr>
-              <a:t>Your pick checklist</a:t>
+              <a:t>Fix as you go: keep it tidy</a:t>
             </a:r>
             <a:endParaRPr lang="en-US" sz="2800" dirty="0"/>
           </a:p>
@@ -5356,27 +5628,124 @@
       </p:sp>
       <p:sp>
         <p:nvSpPr>
-          <p:cNvPr id="3" name="Recap circle 1"/>
+          <p:cNvPr id="3" name="Rule card 1"/>
           <p:cNvSpPr/>
           <p:nvPr/>
         </p:nvSpPr>
         <p:spPr>
           <a:xfrm>
-            <a:off x="868680" y="1371600"/>
-            <a:ext cx="868680" cy="868680"/>
+            <a:off x="457200" y="1325880"/>
+            <a:ext cx="2606040" cy="3246120"/>
+          </a:xfrm>
+          <a:prstGeom prst="roundRect">
+            <a:avLst>
+              <a:gd name="adj" fmla="val 3509"/>
+            </a:avLst>
+          </a:prstGeom>
+          <a:solidFill>
+            <a:schemeClr val="bg1"/>
+          </a:solidFill>
+          <a:ln/>
+        </p:spPr>
+      </p:sp>
+      <p:sp>
+        <p:nvSpPr>
+          <p:cNvPr id="4" name="Rule badge 1"/>
+          <p:cNvSpPr/>
+          <p:nvPr/>
+        </p:nvSpPr>
+        <p:spPr>
+          <a:xfrm>
+            <a:off x="640080" y="1490472"/>
+            <a:ext cx="502920" cy="502920"/>
           </a:xfrm>
           <a:prstGeom prst="ellipse">
             <a:avLst/>
           </a:prstGeom>
           <a:solidFill>
-            <a:schemeClr val="accent1"/>
+            <a:schemeClr val="tx2"/>
           </a:solidFill>
           <a:ln/>
         </p:spPr>
+      </p:sp>
+      <p:sp>
+        <p:nvSpPr>
+          <p:cNvPr id="5" name="Rule letter 1"/>
+          <p:cNvSpPr txBox="1"/>
+          <p:nvPr/>
+        </p:nvSpPr>
+        <p:spPr>
+          <a:xfrm>
+            <a:off x="640080" y="1490472"/>
+            <a:ext cx="502920" cy="502920"/>
+          </a:xfrm>
+          <a:prstGeom prst="rect">
+            <a:avLst/>
+          </a:prstGeom>
+          <a:noFill/>
+          <a:ln/>
+        </p:spPr>
+        <p:txBody>
+          <a:bodyPr wrap="square" lIns="0" tIns="0" rIns="0" bIns="0" rtlCol="0" anchor="ctr"/>
+          <a:lstStyle/>
+          <a:p>
+            <a:pPr algn="ctr" indent="0" marL="0">
+              <a:buNone/>
+            </a:pPr>
+            <a:r>
+              <a:rPr lang="en-US" sz="2200" b="1" dirty="0">
+                <a:solidFill>
+                  <a:schemeClr val="accent1"/>
+                </a:solidFill>
+                <a:latin typeface="Arial" pitchFamily="34" charset="0"/>
+                <a:ea typeface="Arial" pitchFamily="34" charset="-122"/>
+                <a:cs typeface="Arial" pitchFamily="34" charset="-120"/>
+              </a:rPr>
+              <a:t>O</a:t>
+            </a:r>
+            <a:endParaRPr lang="en-US" sz="2200" dirty="0"/>
+          </a:p>
+        </p:txBody>
+      </p:sp>
+      <p:sp>
+        <p:nvSpPr>
+          <p:cNvPr id="6" name="Rule name 1"/>
+          <p:cNvSpPr txBox="1"/>
+          <p:nvPr/>
+        </p:nvSpPr>
+        <p:spPr>
+          <a:xfrm>
+            <a:off x="1280160" y="1490472"/>
+            <a:ext cx="1645920" cy="502920"/>
+          </a:xfrm>
+          <a:prstGeom prst="rect">
+            <a:avLst/>
+          </a:prstGeom>
+          <a:noFill/>
+          <a:ln/>
+        </p:spPr>
+        <p:txBody>
+          <a:bodyPr wrap="square" lIns="0" tIns="0" rIns="0" bIns="0" rtlCol="0" anchor="ctr"/>
+          <a:lstStyle/>
+          <a:p>
+            <a:pPr indent="0" marL="0">
+              <a:buNone/>
+            </a:pPr>
+            <a:r>
+              <a:rPr lang="en-US" sz="1700" b="1" dirty="0">
+                <a:solidFill>
+                  <a:schemeClr val="tx1"/>
+                </a:solidFill>
+              </a:rPr>
+              <a:t>Overstuffing</a:t>
+            </a:r>
+            <a:endParaRPr lang="en-US" sz="1700" dirty="0"/>
+          </a:p>
+        </p:txBody>
       </p:sp>
       <p:pic>
         <p:nvPicPr>
-          <p:cNvPr id="4" name="Recap icon 1" descr="preencoded.png">    </p:cNvPr>
+          <p:cNvPr id="7" name="Rule picture 1" descr="Overstuffing: wrong and right example">    </p:cNvPr>
           <p:cNvPicPr>
             <a:picLocks noChangeAspect="1"/>
           </p:cNvPicPr>
@@ -5390,8 +5759,8 @@
         </p:blipFill>
         <p:spPr>
           <a:xfrm>
-            <a:off x="1088136" y="1591056"/>
-            <a:ext cx="429768" cy="429768"/>
+            <a:off x="640080" y="2162420"/>
+            <a:ext cx="2240280" cy="887240"/>
           </a:xfrm>
           <a:prstGeom prst="rect">
             <a:avLst/>
@@ -5400,14 +5769,14 @@
       </p:pic>
       <p:sp>
         <p:nvSpPr>
-          <p:cNvPr id="5" name="Recap text 1"/>
+          <p:cNvPr id="8" name="Rule detail 1"/>
           <p:cNvSpPr txBox="1"/>
           <p:nvPr/>
         </p:nvSpPr>
         <p:spPr>
           <a:xfrm>
-            <a:off x="457200" y="2423160"/>
-            <a:ext cx="1691640" cy="1097280"/>
+            <a:off x="640080" y="3246120"/>
+            <a:ext cx="2286000" cy="1234440"/>
           </a:xfrm>
           <a:prstGeom prst="rect">
             <a:avLst/>
@@ -5419,21 +5788,128 @@
           <a:bodyPr wrap="square" lIns="0" tIns="0" rIns="0" bIns="0" rtlCol="0" anchor="t"/>
           <a:lstStyle/>
           <a:p>
+            <a:pPr marL="342900" indent="-342900">
+              <a:spcAft>
+                <a:spcPts val="400"/>
+              </a:spcAft>
+              <a:buSzPct val="100000"/>
+              <a:buChar char="•"/>
+            </a:pPr>
+            <a:r>
+              <a:rPr lang="en-US" sz="1400" dirty="0">
+                <a:solidFill>
+                  <a:schemeClr val="accent4"/>
+                </a:solidFill>
+              </a:rPr>
+              <a:t>Never force items back into a full bin</a:t>
+            </a:r>
+            <a:endParaRPr lang="en-US" sz="1400" dirty="0"/>
+          </a:p>
+        </p:txBody>
+      </p:sp>
+      <p:sp>
+        <p:nvSpPr>
+          <p:cNvPr id="9" name="Rule card 2"/>
+          <p:cNvSpPr/>
+          <p:nvPr/>
+        </p:nvSpPr>
+        <p:spPr>
+          <a:xfrm>
+            <a:off x="3246120" y="1325880"/>
+            <a:ext cx="2606040" cy="3246120"/>
+          </a:xfrm>
+          <a:prstGeom prst="roundRect">
+            <a:avLst>
+              <a:gd name="adj" fmla="val 3509"/>
+            </a:avLst>
+          </a:prstGeom>
+          <a:solidFill>
+            <a:schemeClr val="bg1"/>
+          </a:solidFill>
+          <a:ln/>
+        </p:spPr>
+      </p:sp>
+      <p:sp>
+        <p:nvSpPr>
+          <p:cNvPr id="10" name="Rule badge 2"/>
+          <p:cNvSpPr/>
+          <p:nvPr/>
+        </p:nvSpPr>
+        <p:spPr>
+          <a:xfrm>
+            <a:off x="3429000" y="1490472"/>
+            <a:ext cx="502920" cy="502920"/>
+          </a:xfrm>
+          <a:prstGeom prst="ellipse">
+            <a:avLst/>
+          </a:prstGeom>
+          <a:solidFill>
+            <a:schemeClr val="tx2"/>
+          </a:solidFill>
+          <a:ln/>
+        </p:spPr>
+      </p:sp>
+      <p:sp>
+        <p:nvSpPr>
+          <p:cNvPr id="11" name="Rule letter 2"/>
+          <p:cNvSpPr txBox="1"/>
+          <p:nvPr/>
+        </p:nvSpPr>
+        <p:spPr>
+          <a:xfrm>
+            <a:off x="3429000" y="1490472"/>
+            <a:ext cx="502920" cy="502920"/>
+          </a:xfrm>
+          <a:prstGeom prst="rect">
+            <a:avLst/>
+          </a:prstGeom>
+          <a:noFill/>
+          <a:ln/>
+        </p:spPr>
+        <p:txBody>
+          <a:bodyPr wrap="square" lIns="0" tIns="0" rIns="0" bIns="0" rtlCol="0" anchor="ctr"/>
+          <a:lstStyle/>
+          <a:p>
             <a:pPr algn="ctr" indent="0" marL="0">
               <a:buNone/>
             </a:pPr>
             <a:r>
-              <a:rPr lang="en-US" sz="1300" dirty="0">
-                <a:solidFill>
-                  <a:schemeClr val="accent4"/>
-                </a:solidFill>
-              </a:rPr>
-              <a:t>Not picked yet</a:t>
-            </a:r>
-            <a:endParaRPr lang="en-US" sz="1300" dirty="0"/>
-          </a:p>
-          <a:p>
-            <a:pPr algn="ctr" indent="0" marL="0">
+              <a:rPr lang="en-US" sz="2200" b="1" dirty="0">
+                <a:solidFill>
+                  <a:schemeClr val="accent1"/>
+                </a:solidFill>
+                <a:latin typeface="Arial" pitchFamily="34" charset="0"/>
+                <a:ea typeface="Arial" pitchFamily="34" charset="-122"/>
+                <a:cs typeface="Arial" pitchFamily="34" charset="-120"/>
+              </a:rPr>
+              <a:t>S</a:t>
+            </a:r>
+            <a:endParaRPr lang="en-US" sz="2200" dirty="0"/>
+          </a:p>
+        </p:txBody>
+      </p:sp>
+      <p:sp>
+        <p:nvSpPr>
+          <p:cNvPr id="12" name="Rule name 2"/>
+          <p:cNvSpPr txBox="1"/>
+          <p:nvPr/>
+        </p:nvSpPr>
+        <p:spPr>
+          <a:xfrm>
+            <a:off x="4069080" y="1490472"/>
+            <a:ext cx="1645920" cy="502920"/>
+          </a:xfrm>
+          <a:prstGeom prst="rect">
+            <a:avLst/>
+          </a:prstGeom>
+          <a:noFill/>
+          <a:ln/>
+        </p:spPr>
+        <p:txBody>
+          <a:bodyPr wrap="square" lIns="0" tIns="0" rIns="0" bIns="0" rtlCol="0" anchor="ctr"/>
+          <a:lstStyle/>
+          <a:p>
+            <a:pPr indent="0" marL="0">
               <a:buNone/>
             </a:pPr>
             <a:r>
@@ -5442,35 +5918,15 @@
                   <a:schemeClr val="tx1"/>
                 </a:solidFill>
               </a:rPr>
-              <a:t>Amnesty</a:t>
-            </a:r>
-            <a:endParaRPr lang="en-US" sz="1300" dirty="0"/>
-          </a:p>
-        </p:txBody>
-      </p:sp>
-      <p:sp>
-        <p:nvSpPr>
-          <p:cNvPr id="6" name="Recap circle 2"/>
-          <p:cNvSpPr/>
-          <p:nvPr/>
-        </p:nvSpPr>
-        <p:spPr>
-          <a:xfrm>
-            <a:off x="2697480" y="1371600"/>
-            <a:ext cx="868680" cy="868680"/>
-          </a:xfrm>
-          <a:prstGeom prst="ellipse">
-            <a:avLst/>
-          </a:prstGeom>
-          <a:solidFill>
-            <a:schemeClr val="accent1"/>
-          </a:solidFill>
-          <a:ln/>
-        </p:spPr>
+              <a:t>Stacking</a:t>
+            </a:r>
+            <a:endParaRPr lang="en-US" sz="1700" dirty="0"/>
+          </a:p>
+        </p:txBody>
       </p:sp>
       <p:pic>
         <p:nvPicPr>
-          <p:cNvPr id="7" name="Recap icon 2" descr="preencoded.png">    </p:cNvPr>
+          <p:cNvPr id="13" name="Rule picture 2" descr="Stacking: wrong and right example">    </p:cNvPr>
           <p:cNvPicPr>
             <a:picLocks noChangeAspect="1"/>
           </p:cNvPicPr>
@@ -5484,8 +5940,8 @@
         </p:blipFill>
         <p:spPr>
           <a:xfrm>
-            <a:off x="2916936" y="1591056"/>
-            <a:ext cx="429768" cy="429768"/>
+            <a:off x="3429000" y="2173511"/>
+            <a:ext cx="2240280" cy="865059"/>
           </a:xfrm>
           <a:prstGeom prst="rect">
             <a:avLst/>
@@ -5494,14 +5950,14 @@
       </p:pic>
       <p:sp>
         <p:nvSpPr>
-          <p:cNvPr id="8" name="Recap text 2"/>
+          <p:cNvPr id="14" name="Rule detail 2"/>
           <p:cNvSpPr txBox="1"/>
           <p:nvPr/>
         </p:nvSpPr>
         <p:spPr>
           <a:xfrm>
-            <a:off x="2286000" y="2423160"/>
-            <a:ext cx="1691640" cy="1097280"/>
+            <a:off x="3429000" y="3246120"/>
+            <a:ext cx="2286000" cy="1234440"/>
           </a:xfrm>
           <a:prstGeom prst="rect">
             <a:avLst/>
@@ -5513,195 +5969,22 @@
           <a:bodyPr wrap="square" lIns="0" tIns="0" rIns="0" bIns="0" rtlCol="0" anchor="t"/>
           <a:lstStyle/>
           <a:p>
-            <a:pPr algn="ctr" indent="0" marL="0">
-              <a:buNone/>
-            </a:pPr>
-            <a:r>
-              <a:rPr lang="en-US" sz="1300" dirty="0">
+            <a:pPr marL="342900" indent="-342900">
+              <a:spcAft>
+                <a:spcPts val="400"/>
+              </a:spcAft>
+              <a:buSzPct val="100000"/>
+              <a:buChar char="•"/>
+            </a:pPr>
+            <a:r>
+              <a:rPr lang="en-US" sz="1400" dirty="0">
                 <a:solidFill>
                   <a:schemeClr val="accent4"/>
                 </a:solidFill>
               </a:rPr>
-              <a:t>Already picked</a:t>
-            </a:r>
-            <a:endParaRPr lang="en-US" sz="1300" dirty="0"/>
-          </a:p>
-          <a:p>
-            <a:pPr algn="ctr" indent="0" marL="0">
-              <a:buNone/>
-            </a:pPr>
-            <a:r>
-              <a:rPr lang="en-US" sz="1700" b="1" dirty="0">
-                <a:solidFill>
-                  <a:schemeClr val="tx1"/>
-                </a:solidFill>
-              </a:rPr>
-              <a:t>Outbound problem solve</a:t>
-            </a:r>
-            <a:endParaRPr lang="en-US" sz="1300" dirty="0"/>
-          </a:p>
-        </p:txBody>
-      </p:sp>
-      <p:sp>
-        <p:nvSpPr>
-          <p:cNvPr id="9" name="Recap circle 3"/>
-          <p:cNvSpPr/>
-          <p:nvPr/>
-        </p:nvSpPr>
-        <p:spPr>
-          <a:xfrm>
-            <a:off x="4526280" y="1371600"/>
-            <a:ext cx="868680" cy="868680"/>
-          </a:xfrm>
-          <a:prstGeom prst="ellipse">
-            <a:avLst/>
-          </a:prstGeom>
-          <a:solidFill>
-            <a:schemeClr val="accent1"/>
-          </a:solidFill>
-          <a:ln/>
-        </p:spPr>
-      </p:sp>
-      <p:pic>
-        <p:nvPicPr>
-          <p:cNvPr id="10" name="Recap icon 3" descr="preencoded.png">    </p:cNvPr>
-          <p:cNvPicPr>
-            <a:picLocks noChangeAspect="1"/>
-          </p:cNvPicPr>
-          <p:nvPr/>
-        </p:nvPicPr>
-        <p:blipFill>
-          <a:blip r:embed="rId3"/>
-          <a:stretch>
-            <a:fillRect/>
-          </a:stretch>
-        </p:blipFill>
-        <p:spPr>
-          <a:xfrm>
-            <a:off x="4745736" y="1591056"/>
-            <a:ext cx="429768" cy="429768"/>
-          </a:xfrm>
-          <a:prstGeom prst="rect">
-            <a:avLst/>
-          </a:prstGeom>
-        </p:spPr>
-      </p:pic>
-      <p:sp>
-        <p:nvSpPr>
-          <p:cNvPr id="11" name="Recap text 3"/>
-          <p:cNvSpPr txBox="1"/>
-          <p:nvPr/>
-        </p:nvSpPr>
-        <p:spPr>
-          <a:xfrm>
-            <a:off x="4114800" y="2423160"/>
-            <a:ext cx="1691640" cy="1097280"/>
-          </a:xfrm>
-          <a:prstGeom prst="rect">
-            <a:avLst/>
-          </a:prstGeom>
-          <a:noFill/>
-          <a:ln/>
-        </p:spPr>
-        <p:txBody>
-          <a:bodyPr wrap="square" lIns="0" tIns="0" rIns="0" bIns="0" rtlCol="0" anchor="t"/>
-          <a:lstStyle/>
-          <a:p>
-            <a:pPr algn="ctr" indent="0" marL="0">
-              <a:buNone/>
-            </a:pPr>
-            <a:r>
-              <a:rPr lang="en-US" sz="1300" dirty="0">
-                <a:solidFill>
-                  <a:schemeClr val="accent4"/>
-                </a:solidFill>
-              </a:rPr>
-              <a:t>Every bin you touch</a:t>
-            </a:r>
-            <a:endParaRPr lang="en-US" sz="1300" dirty="0"/>
-          </a:p>
-          <a:p>
-            <a:pPr algn="ctr" indent="0" marL="0">
-              <a:buNone/>
-            </a:pPr>
-            <a:r>
-              <a:rPr lang="en-US" sz="1700" b="1" dirty="0">
-                <a:solidFill>
-                  <a:schemeClr val="tx1"/>
-                </a:solidFill>
-              </a:rPr>
-              <a:t>One at a time, fix as you go</a:t>
-            </a:r>
-            <a:endParaRPr lang="en-US" sz="1300" dirty="0"/>
-          </a:p>
-        </p:txBody>
-      </p:sp>
-      <p:sp>
-        <p:nvSpPr>
-          <p:cNvPr id="12" name="Goal card"/>
-          <p:cNvSpPr/>
-          <p:nvPr/>
-        </p:nvSpPr>
-        <p:spPr>
-          <a:xfrm>
-            <a:off x="457200" y="3749040"/>
-            <a:ext cx="5394960" cy="777240"/>
-          </a:xfrm>
-          <a:prstGeom prst="roundRect">
-            <a:avLst>
-              <a:gd name="adj" fmla="val 11765"/>
-            </a:avLst>
-          </a:prstGeom>
-          <a:solidFill>
-            <a:schemeClr val="tx2"/>
-          </a:solidFill>
-          <a:ln/>
-        </p:spPr>
-      </p:sp>
-      <p:sp>
-        <p:nvSpPr>
-          <p:cNvPr id="13" name="Goal text"/>
-          <p:cNvSpPr txBox="1"/>
-          <p:nvPr/>
-        </p:nvSpPr>
-        <p:spPr>
-          <a:xfrm>
-            <a:off x="731520" y="3749040"/>
-            <a:ext cx="4846320" cy="777240"/>
-          </a:xfrm>
-          <a:prstGeom prst="rect">
-            <a:avLst/>
-          </a:prstGeom>
-          <a:noFill/>
-          <a:ln/>
-        </p:spPr>
-        <p:txBody>
-          <a:bodyPr wrap="square" lIns="0" tIns="0" rIns="0" bIns="0" rtlCol="0" anchor="ctr"/>
-          <a:lstStyle/>
-          <a:p>
-            <a:pPr indent="0" marL="0">
-              <a:buNone/>
-            </a:pPr>
-            <a:r>
-              <a:rPr lang="en-US" sz="1600" b="1" dirty="0">
-                <a:solidFill>
-                  <a:srgbClr val="9EDFF7"/>
-                </a:solidFill>
-              </a:rPr>
-              <a:t>Goal: </a:t>
-            </a:r>
-            <a:pPr indent="0" marL="0">
-              <a:buNone/>
-            </a:pPr>
-            <a:r>
-              <a:rPr lang="en-US" sz="1600" dirty="0">
-                <a:solidFill>
-                  <a:schemeClr val="bg1"/>
-                </a:solidFill>
-              </a:rPr>
-              <a:t>an accurate wAPMT, fewer units falling, happier customers.</a:t>
-            </a:r>
-            <a:endParaRPr lang="en-US" sz="1600" dirty="0"/>
+              <a:t>Keep everything below the retention bands</a:t>
+            </a:r>
+            <a:endParaRPr lang="en-US" sz="1400" dirty="0"/>
           </a:p>
         </p:txBody>
       </p:sp>

</xml_diff>

<commit_message>
One slide per ROBOTSS letter with large highlighted wrong/right examples
Co-Authored-By: Claude Opus 5.5 <noreply@anthropic.com>
Claude-Session: https://claude.ai/code/session_01Cr6d8mb1XkHfhN1yyjHEjG
</commit_message>
<xml_diff>
--- a/APMT_Coaching_Pick_to_Rebin.pptx
+++ b/APMT_Coaching_Pick_to_Rebin.pptx
@@ -16,9 +16,11 @@
     <p:sldId id="264" r:id="rId10"/>
     <p:sldId id="265" r:id="rId11"/>
     <p:sldId id="266" r:id="rId12"/>
+    <p:sldId id="267" r:id="rId13"/>
+    <p:sldId id="268" r:id="rId14"/>
   </p:sldIdLst>
   <p:notesMasterIdLst>
-    <p:notesMasterId r:id="rId13"/>
+    <p:notesMasterId r:id="rId15"/>
   </p:notesMasterIdLst>
   <p:sldSz cx="9144000" cy="5143500"/>
   <p:notesSz cx="5143500" cy="9144000"/>
@@ -117,7 +119,7 @@
   <p:extLst>
     <p:ext uri="{521415D9-36F7-43E2-AB2F-B90AF26B5E84}">
       <p14:sectionLst xmlns:p14="http://schemas.microsoft.com/office/powerpoint/2010/main">
-        <p14:section name="Intro" id="{6ec9d610-bde1-2081-2570-3d95ebc5563d}">
+        <p14:section name="Intro" id="{05f6309b-c00d-fb4a-16dc-74631591e648}">
           <p14:sldIdLst>
             <p14:sldId id="256"/>
             <p14:sldId id="257"/>
@@ -126,18 +128,20 @@
             <p14:sldId id="260"/>
           </p14:sldIdLst>
         </p14:section>
-        <p14:section name="Bin etiquette" id="{23c4aaaf-a17a-4fab-f42c-432c5e8be6d2}">
+        <p14:section name="Bin etiquette" id="{c577cd64-002e-99d8-3f1c-d3e9567e4b98}">
           <p14:sldIdLst>
             <p14:sldId id="261"/>
             <p14:sldId id="262"/>
             <p14:sldId id="263"/>
             <p14:sldId id="264"/>
+            <p14:sldId id="265"/>
+            <p14:sldId id="266"/>
           </p14:sldIdLst>
         </p14:section>
-        <p14:section name="Wrap-up" id="{0b6a2282-2435-a14c-0307-0c31071c38d9}">
+        <p14:section name="Wrap-up" id="{6d1f7199-341d-8dbd-bb1f-39f562932228}">
           <p14:sldIdLst>
-            <p14:sldId id="265"/>
-            <p14:sldId id="266"/>
+            <p14:sldId id="267"/>
+            <p14:sldId id="268"/>
           </p14:sldIdLst>
         </p14:section>
       </p14:sectionLst>
@@ -632,7 +636,7 @@
           <a:p>
             <a:r>
               <a:rPr lang="en-US" dirty="0"/>
-              <a:t>So here's your pick checklist. Found an item that hasn't been picked yet? That's amnesty. Found one that's already been picked? That's outbound problem solve, not amnesty. And on every bin you touch, handle one item at a time and fix as you go. That keeps our wAPMT accurate, stops units falling, and gets our customers what they ordered.</a:t>
+              <a:t>Overstuffing. On the left, items have been forced in and the bin is bulging. That damages products, and it's the bin most likely to spill. On the right, everything fits with room to pick. Never force items back into a full bin.</a:t>
             </a:r>
             <a:endParaRPr lang="en-US" dirty="0"/>
           </a:p>
@@ -720,7 +724,7 @@
           <a:p>
             <a:r>
               <a:rPr lang="en-US" dirty="0"/>
-              <a:t>Small fixes make a big impact. Thanks for watching, and thanks for looking after every bin, every time. If you have any questions, speak to your Process Guide, your Area Manager, or the ICQA team. And please take a second to rate this video.</a:t>
+              <a:t>And stacking. On the left, different items are piled on top of each other, right up to the bands. On the right, they stand side by side, below the bands. Keep everything below the retention bands. A few seconds from you stops units falling as the pod moves.</a:t>
             </a:r>
             <a:endParaRPr lang="en-US" dirty="0"/>
           </a:p>
@@ -744,6 +748,182 @@
             <a:fld id="{F7021451-1387-4CA6-816F-3879F97B5CBC}" type="slidenum">
               <a:rPr lang="en-US"/>
               <a:t>11</a:t>
+            </a:fld>
+            <a:endParaRPr lang="en-US"/>
+          </a:p>
+        </p:txBody>
+      </p:sp>
+    </p:spTree>
+    <p:extLst>
+      <p:ext uri="{BB962C8B-B14F-4D97-AF65-F5344CB8AC3E}">
+        <p14:creationId xmlns:p14="http://schemas.microsoft.com/office/powerpoint/2010/main" val="1024086991"/>
+      </p:ext>
+    </p:extLst>
+  </p:cSld>
+  <p:clrMapOvr>
+    <a:masterClrMapping/>
+  </p:clrMapOvr>
+</p:notes>
+</file>
+
+<file path=ppt/notesSlides/notesSlide12.xml><?xml version="1.0" encoding="utf-8"?>
+<p:notes xmlns:a="http://schemas.openxmlformats.org/drawingml/2006/main" xmlns:r="http://schemas.openxmlformats.org/officeDocument/2006/relationships" xmlns:p="http://schemas.openxmlformats.org/presentationml/2006/main">
+  <p:cSld>
+    <p:spTree>
+      <p:nvGrpSpPr>
+        <p:cNvPr id="1" name=""/>
+        <p:cNvGrpSpPr/>
+        <p:nvPr/>
+      </p:nvGrpSpPr>
+      <p:grpSpPr>
+        <a:xfrm>
+          <a:off x="0" y="0"/>
+          <a:ext cx="0" cy="0"/>
+          <a:chOff x="0" y="0"/>
+          <a:chExt cx="0" cy="0"/>
+        </a:xfrm>
+      </p:grpSpPr>
+      <p:sp>
+        <p:nvSpPr>
+          <p:cNvPr id="2" name="Slide Image Placeholder 1"/>
+          <p:cNvSpPr>
+            <a:spLocks noGrp="1" noRot="1" noChangeAspect="1"/>
+          </p:cNvSpPr>
+          <p:nvPr>
+            <p:ph type="sldImg"/>
+          </p:nvPr>
+        </p:nvSpPr>
+        <p:spPr/>
+      </p:sp>
+      <p:sp>
+        <p:nvSpPr>
+          <p:cNvPr id="3" name="Notes Placeholder 2"/>
+          <p:cNvSpPr>
+            <a:spLocks noGrp="1"/>
+          </p:cNvSpPr>
+          <p:nvPr>
+            <p:ph type="body" idx="1"/>
+          </p:nvPr>
+        </p:nvSpPr>
+        <p:spPr/>
+        <p:txBody>
+          <a:bodyPr/>
+          <a:lstStyle/>
+          <a:p>
+            <a:r>
+              <a:rPr lang="en-US" dirty="0"/>
+              <a:t>So here's your pick checklist. Found an item that hasn't been picked yet? That's amnesty. Found one that's already been picked? That's outbound problem solve, not amnesty. And on every bin you touch, handle one item at a time and fix as you go. That keeps our wAPMT accurate, stops units falling, and gets our customers what they ordered.</a:t>
+            </a:r>
+            <a:endParaRPr lang="en-US" dirty="0"/>
+          </a:p>
+        </p:txBody>
+      </p:sp>
+      <p:sp>
+        <p:nvSpPr>
+          <p:cNvPr id="4" name="Slide Number Placeholder 3"/>
+          <p:cNvSpPr>
+            <a:spLocks noGrp="1"/>
+          </p:cNvSpPr>
+          <p:nvPr>
+            <p:ph type="sldNum" sz="quarter" idx="10"/>
+          </p:nvPr>
+        </p:nvSpPr>
+        <p:spPr/>
+        <p:txBody>
+          <a:bodyPr/>
+          <a:lstStyle/>
+          <a:p>
+            <a:fld id="{F7021451-1387-4CA6-816F-3879F97B5CBC}" type="slidenum">
+              <a:rPr lang="en-US"/>
+              <a:t>12</a:t>
+            </a:fld>
+            <a:endParaRPr lang="en-US"/>
+          </a:p>
+        </p:txBody>
+      </p:sp>
+    </p:spTree>
+    <p:extLst>
+      <p:ext uri="{BB962C8B-B14F-4D97-AF65-F5344CB8AC3E}">
+        <p14:creationId xmlns:p14="http://schemas.microsoft.com/office/powerpoint/2010/main" val="1024086991"/>
+      </p:ext>
+    </p:extLst>
+  </p:cSld>
+  <p:clrMapOvr>
+    <a:masterClrMapping/>
+  </p:clrMapOvr>
+</p:notes>
+</file>
+
+<file path=ppt/notesSlides/notesSlide13.xml><?xml version="1.0" encoding="utf-8"?>
+<p:notes xmlns:a="http://schemas.openxmlformats.org/drawingml/2006/main" xmlns:r="http://schemas.openxmlformats.org/officeDocument/2006/relationships" xmlns:p="http://schemas.openxmlformats.org/presentationml/2006/main">
+  <p:cSld>
+    <p:spTree>
+      <p:nvGrpSpPr>
+        <p:cNvPr id="1" name=""/>
+        <p:cNvGrpSpPr/>
+        <p:nvPr/>
+      </p:nvGrpSpPr>
+      <p:grpSpPr>
+        <a:xfrm>
+          <a:off x="0" y="0"/>
+          <a:ext cx="0" cy="0"/>
+          <a:chOff x="0" y="0"/>
+          <a:chExt cx="0" cy="0"/>
+        </a:xfrm>
+      </p:grpSpPr>
+      <p:sp>
+        <p:nvSpPr>
+          <p:cNvPr id="2" name="Slide Image Placeholder 1"/>
+          <p:cNvSpPr>
+            <a:spLocks noGrp="1" noRot="1" noChangeAspect="1"/>
+          </p:cNvSpPr>
+          <p:nvPr>
+            <p:ph type="sldImg"/>
+          </p:nvPr>
+        </p:nvSpPr>
+        <p:spPr/>
+      </p:sp>
+      <p:sp>
+        <p:nvSpPr>
+          <p:cNvPr id="3" name="Notes Placeholder 2"/>
+          <p:cNvSpPr>
+            <a:spLocks noGrp="1"/>
+          </p:cNvSpPr>
+          <p:nvPr>
+            <p:ph type="body" idx="1"/>
+          </p:nvPr>
+        </p:nvSpPr>
+        <p:spPr/>
+        <p:txBody>
+          <a:bodyPr/>
+          <a:lstStyle/>
+          <a:p>
+            <a:r>
+              <a:rPr lang="en-US" dirty="0"/>
+              <a:t>Small fixes make a big impact. Thanks for watching, and thanks for looking after every bin, every time. If you have any questions, speak to your Process Guide, your Area Manager, or the ICQA team. And please take a second to rate this video.</a:t>
+            </a:r>
+            <a:endParaRPr lang="en-US" dirty="0"/>
+          </a:p>
+        </p:txBody>
+      </p:sp>
+      <p:sp>
+        <p:nvSpPr>
+          <p:cNvPr id="4" name="Slide Number Placeholder 3"/>
+          <p:cNvSpPr>
+            <a:spLocks noGrp="1"/>
+          </p:cNvSpPr>
+          <p:nvPr>
+            <p:ph type="sldNum" sz="quarter" idx="10"/>
+          </p:nvPr>
+        </p:nvSpPr>
+        <p:spPr/>
+        <p:txBody>
+          <a:bodyPr/>
+          <a:lstStyle/>
+          <a:p>
+            <a:fld id="{F7021451-1387-4CA6-816F-3879F97B5CBC}" type="slidenum">
+              <a:rPr lang="en-US"/>
+              <a:t>13</a:t>
             </a:fld>
             <a:endParaRPr lang="en-US"/>
           </a:p>
@@ -1336,7 +1516,7 @@
           <a:p>
             <a:r>
               <a:rPr lang="en-US" dirty="0"/>
-              <a:t>Second, fix as you go. Whenever your hands are in a bin, use the ROBOTSS rules to leave it better than you found it. No overhang: if anything is sticking out, push it fully back inside. Blocking: don't leave small items hidden behind big ones, and stand flat items upright so they can't slip between the bands.</a:t>
+              <a:t>Second, fix as you go. Whenever your hands are in a bin, use the ROBOTSS rules to leave it better than you found it. Look at this first example. On the left, the box is sticking out past the edge of the bin. That's overhang, and it can catch as the pod moves. On the right, everything sits fully inside. If you see something sticking out, push it back in.</a:t>
             </a:r>
             <a:endParaRPr lang="en-US" dirty="0"/>
           </a:p>
@@ -1424,7 +1604,7 @@
           <a:p>
             <a:r>
               <a:rPr lang="en-US" dirty="0"/>
-              <a:t>Overstuffing: never force items back into a full bin, because that's how products get damaged and spill out. And stacking: keep everything below the retention bands. A few seconds from you stops units falling as the pod moves.</a:t>
+              <a:t>Next, blocking. On the left, a flat item lying across the front hides everything behind it. On the right, every item can be seen from the front. Don't leave small items hidden behind big ones, and stand flat items upright so they can't slip between the bands.</a:t>
             </a:r>
             <a:endParaRPr lang="en-US" dirty="0"/>
           </a:p>
@@ -2308,7 +2488,7 @@
                   <a:schemeClr val="tx1"/>
                 </a:solidFill>
               </a:rPr>
-              <a:t>Your pick checklist</a:t>
+              <a:t>O: Overstuffing</a:t>
             </a:r>
             <a:endParaRPr lang="en-US" sz="2800" dirty="0"/>
           </a:p>
@@ -2316,27 +2496,34 @@
       </p:sp>
       <p:sp>
         <p:nvSpPr>
-          <p:cNvPr id="3" name="Recap circle 1"/>
+          <p:cNvPr id="3" name="Wrong panel"/>
           <p:cNvSpPr/>
           <p:nvPr/>
         </p:nvSpPr>
         <p:spPr>
           <a:xfrm>
-            <a:off x="868680" y="1371600"/>
-            <a:ext cx="868680" cy="868680"/>
-          </a:xfrm>
-          <a:prstGeom prst="ellipse">
-            <a:avLst/>
+            <a:off x="457200" y="1325880"/>
+            <a:ext cx="2606040" cy="2788920"/>
+          </a:xfrm>
+          <a:prstGeom prst="roundRect">
+            <a:avLst>
+              <a:gd name="adj" fmla="val 3509"/>
+            </a:avLst>
           </a:prstGeom>
           <a:solidFill>
-            <a:schemeClr val="accent1"/>
+            <a:schemeClr val="bg1"/>
           </a:solidFill>
-          <a:ln/>
+          <a:ln w="38100">
+            <a:solidFill>
+              <a:srgbClr val="D64545"/>
+            </a:solidFill>
+            <a:prstDash val="solid"/>
+          </a:ln>
         </p:spPr>
       </p:sp>
       <p:pic>
         <p:nvPicPr>
-          <p:cNvPr id="4" name="Recap icon 1" descr="preencoded.png">    </p:cNvPr>
+          <p:cNvPr id="4" name="Wrong picture" descr="Overstuffing: wrong example. Items forced in, the bin is bulging">    </p:cNvPr>
           <p:cNvPicPr>
             <a:picLocks noChangeAspect="1"/>
           </p:cNvPicPr>
@@ -2350,8 +2537,8 @@
         </p:blipFill>
         <p:spPr>
           <a:xfrm>
-            <a:off x="1088136" y="1591056"/>
-            <a:ext cx="429768" cy="429768"/>
+            <a:off x="619733" y="1417320"/>
+            <a:ext cx="2280974" cy="2103120"/>
           </a:xfrm>
           <a:prstGeom prst="rect">
             <a:avLst/>
@@ -2360,14 +2547,14 @@
       </p:pic>
       <p:sp>
         <p:nvSpPr>
-          <p:cNvPr id="5" name="Recap text 1"/>
+          <p:cNvPr id="5" name="Wrong caption"/>
           <p:cNvSpPr txBox="1"/>
           <p:nvPr/>
         </p:nvSpPr>
         <p:spPr>
           <a:xfrm>
-            <a:off x="457200" y="2423160"/>
-            <a:ext cx="1691640" cy="1097280"/>
+            <a:off x="594360" y="3547872"/>
+            <a:ext cx="2331720" cy="502920"/>
           </a:xfrm>
           <a:prstGeom prst="rect">
             <a:avLst/>
@@ -2376,61 +2563,65 @@
           <a:ln/>
         </p:spPr>
         <p:txBody>
-          <a:bodyPr wrap="square" lIns="0" tIns="0" rIns="0" bIns="0" rtlCol="0" anchor="t"/>
+          <a:bodyPr wrap="square" lIns="0" tIns="0" rIns="0" bIns="0" rtlCol="0" anchor="ctr"/>
           <a:lstStyle/>
           <a:p>
             <a:pPr algn="ctr" indent="0" marL="0">
               <a:buNone/>
             </a:pPr>
             <a:r>
+              <a:rPr lang="en-US" sz="1300" b="1" dirty="0">
+                <a:solidFill>
+                  <a:schemeClr val="accent3"/>
+                </a:solidFill>
+              </a:rPr>
+              <a:t>WRONG: </a:t>
+            </a:r>
+            <a:pPr algn="ctr" indent="0" marL="0">
+              <a:buNone/>
+            </a:pPr>
+            <a:r>
               <a:rPr lang="en-US" sz="1300" dirty="0">
                 <a:solidFill>
-                  <a:schemeClr val="accent4"/>
-                </a:solidFill>
-              </a:rPr>
-              <a:t>Not picked yet</a:t>
+                  <a:schemeClr val="tx1"/>
+                </a:solidFill>
+              </a:rPr>
+              <a:t>Items forced in, the bin is bulging</a:t>
             </a:r>
             <a:endParaRPr lang="en-US" sz="1300" dirty="0"/>
           </a:p>
-          <a:p>
-            <a:pPr algn="ctr" indent="0" marL="0">
-              <a:buNone/>
-            </a:pPr>
-            <a:r>
-              <a:rPr lang="en-US" sz="1700" b="1" dirty="0">
-                <a:solidFill>
-                  <a:schemeClr val="tx1"/>
-                </a:solidFill>
-              </a:rPr>
-              <a:t>Amnesty</a:t>
-            </a:r>
-            <a:endParaRPr lang="en-US" sz="1300" dirty="0"/>
-          </a:p>
-        </p:txBody>
-      </p:sp>
-      <p:sp>
-        <p:nvSpPr>
-          <p:cNvPr id="6" name="Recap circle 2"/>
+        </p:txBody>
+      </p:sp>
+      <p:sp>
+        <p:nvSpPr>
+          <p:cNvPr id="6" name="Right panel"/>
           <p:cNvSpPr/>
           <p:nvPr/>
         </p:nvSpPr>
         <p:spPr>
           <a:xfrm>
-            <a:off x="2697480" y="1371600"/>
-            <a:ext cx="868680" cy="868680"/>
-          </a:xfrm>
-          <a:prstGeom prst="ellipse">
-            <a:avLst/>
+            <a:off x="3246120" y="1325880"/>
+            <a:ext cx="2606040" cy="2788920"/>
+          </a:xfrm>
+          <a:prstGeom prst="roundRect">
+            <a:avLst>
+              <a:gd name="adj" fmla="val 3509"/>
+            </a:avLst>
           </a:prstGeom>
           <a:solidFill>
-            <a:schemeClr val="accent1"/>
+            <a:schemeClr val="bg1"/>
           </a:solidFill>
-          <a:ln/>
+          <a:ln w="38100">
+            <a:solidFill>
+              <a:srgbClr val="2E7D32"/>
+            </a:solidFill>
+            <a:prstDash val="solid"/>
+          </a:ln>
         </p:spPr>
       </p:sp>
       <p:pic>
         <p:nvPicPr>
-          <p:cNvPr id="7" name="Recap icon 2" descr="preencoded.png">    </p:cNvPr>
+          <p:cNvPr id="7" name="Right picture" descr="Overstuffing: right example. Items fit with room to pick">    </p:cNvPr>
           <p:cNvPicPr>
             <a:picLocks noChangeAspect="1"/>
           </p:cNvPicPr>
@@ -2444,8 +2635,8 @@
         </p:blipFill>
         <p:spPr>
           <a:xfrm>
-            <a:off x="2916936" y="1591056"/>
-            <a:ext cx="429768" cy="429768"/>
+            <a:off x="3413099" y="1417320"/>
+            <a:ext cx="2272081" cy="2103120"/>
           </a:xfrm>
           <a:prstGeom prst="rect">
             <a:avLst/>
@@ -2454,14 +2645,14 @@
       </p:pic>
       <p:sp>
         <p:nvSpPr>
-          <p:cNvPr id="8" name="Recap text 2"/>
+          <p:cNvPr id="8" name="Right caption"/>
           <p:cNvSpPr txBox="1"/>
           <p:nvPr/>
         </p:nvSpPr>
         <p:spPr>
           <a:xfrm>
-            <a:off x="2286000" y="2423160"/>
-            <a:ext cx="1691640" cy="1097280"/>
+            <a:off x="3383280" y="3547872"/>
+            <a:ext cx="2331720" cy="502920"/>
           </a:xfrm>
           <a:prstGeom prst="rect">
             <a:avLst/>
@@ -2470,146 +2661,49 @@
           <a:ln/>
         </p:spPr>
         <p:txBody>
-          <a:bodyPr wrap="square" lIns="0" tIns="0" rIns="0" bIns="0" rtlCol="0" anchor="t"/>
+          <a:bodyPr wrap="square" lIns="0" tIns="0" rIns="0" bIns="0" rtlCol="0" anchor="ctr"/>
           <a:lstStyle/>
           <a:p>
             <a:pPr algn="ctr" indent="0" marL="0">
               <a:buNone/>
             </a:pPr>
             <a:r>
+              <a:rPr lang="en-US" sz="1300" b="1" dirty="0">
+                <a:solidFill>
+                  <a:srgbClr val="2E7D32"/>
+                </a:solidFill>
+              </a:rPr>
+              <a:t>RIGHT: </a:t>
+            </a:r>
+            <a:pPr algn="ctr" indent="0" marL="0">
+              <a:buNone/>
+            </a:pPr>
+            <a:r>
               <a:rPr lang="en-US" sz="1300" dirty="0">
                 <a:solidFill>
-                  <a:schemeClr val="accent4"/>
-                </a:solidFill>
-              </a:rPr>
-              <a:t>Already picked</a:t>
+                  <a:schemeClr val="tx1"/>
+                </a:solidFill>
+              </a:rPr>
+              <a:t>Items fit with room to pick</a:t>
             </a:r>
             <a:endParaRPr lang="en-US" sz="1300" dirty="0"/>
           </a:p>
-          <a:p>
-            <a:pPr algn="ctr" indent="0" marL="0">
-              <a:buNone/>
-            </a:pPr>
-            <a:r>
-              <a:rPr lang="en-US" sz="1700" b="1" dirty="0">
-                <a:solidFill>
-                  <a:schemeClr val="tx1"/>
-                </a:solidFill>
-              </a:rPr>
-              <a:t>Outbound problem solve</a:t>
-            </a:r>
-            <a:endParaRPr lang="en-US" sz="1300" dirty="0"/>
-          </a:p>
-        </p:txBody>
-      </p:sp>
-      <p:sp>
-        <p:nvSpPr>
-          <p:cNvPr id="9" name="Recap circle 3"/>
+        </p:txBody>
+      </p:sp>
+      <p:sp>
+        <p:nvSpPr>
+          <p:cNvPr id="9" name="Rule card"/>
           <p:cNvSpPr/>
           <p:nvPr/>
         </p:nvSpPr>
         <p:spPr>
           <a:xfrm>
-            <a:off x="4526280" y="1371600"/>
-            <a:ext cx="868680" cy="868680"/>
-          </a:xfrm>
-          <a:prstGeom prst="ellipse">
-            <a:avLst/>
-          </a:prstGeom>
-          <a:solidFill>
-            <a:schemeClr val="accent1"/>
-          </a:solidFill>
-          <a:ln/>
-        </p:spPr>
-      </p:sp>
-      <p:pic>
-        <p:nvPicPr>
-          <p:cNvPr id="10" name="Recap icon 3" descr="preencoded.png">    </p:cNvPr>
-          <p:cNvPicPr>
-            <a:picLocks noChangeAspect="1"/>
-          </p:cNvPicPr>
-          <p:nvPr/>
-        </p:nvPicPr>
-        <p:blipFill>
-          <a:blip r:embed="rId3"/>
-          <a:stretch>
-            <a:fillRect/>
-          </a:stretch>
-        </p:blipFill>
-        <p:spPr>
-          <a:xfrm>
-            <a:off x="4745736" y="1591056"/>
-            <a:ext cx="429768" cy="429768"/>
-          </a:xfrm>
-          <a:prstGeom prst="rect">
-            <a:avLst/>
-          </a:prstGeom>
-        </p:spPr>
-      </p:pic>
-      <p:sp>
-        <p:nvSpPr>
-          <p:cNvPr id="11" name="Recap text 3"/>
-          <p:cNvSpPr txBox="1"/>
-          <p:nvPr/>
-        </p:nvSpPr>
-        <p:spPr>
-          <a:xfrm>
-            <a:off x="4114800" y="2423160"/>
-            <a:ext cx="1691640" cy="1097280"/>
-          </a:xfrm>
-          <a:prstGeom prst="rect">
-            <a:avLst/>
-          </a:prstGeom>
-          <a:noFill/>
-          <a:ln/>
-        </p:spPr>
-        <p:txBody>
-          <a:bodyPr wrap="square" lIns="0" tIns="0" rIns="0" bIns="0" rtlCol="0" anchor="t"/>
-          <a:lstStyle/>
-          <a:p>
-            <a:pPr algn="ctr" indent="0" marL="0">
-              <a:buNone/>
-            </a:pPr>
-            <a:r>
-              <a:rPr lang="en-US" sz="1300" dirty="0">
-                <a:solidFill>
-                  <a:schemeClr val="accent4"/>
-                </a:solidFill>
-              </a:rPr>
-              <a:t>Every bin you touch</a:t>
-            </a:r>
-            <a:endParaRPr lang="en-US" sz="1300" dirty="0"/>
-          </a:p>
-          <a:p>
-            <a:pPr algn="ctr" indent="0" marL="0">
-              <a:buNone/>
-            </a:pPr>
-            <a:r>
-              <a:rPr lang="en-US" sz="1700" b="1" dirty="0">
-                <a:solidFill>
-                  <a:schemeClr val="tx1"/>
-                </a:solidFill>
-              </a:rPr>
-              <a:t>One at a time, fix as you go</a:t>
-            </a:r>
-            <a:endParaRPr lang="en-US" sz="1300" dirty="0"/>
-          </a:p>
-        </p:txBody>
-      </p:sp>
-      <p:sp>
-        <p:nvSpPr>
-          <p:cNvPr id="12" name="Goal card"/>
-          <p:cNvSpPr/>
-          <p:nvPr/>
-        </p:nvSpPr>
-        <p:spPr>
-          <a:xfrm>
-            <a:off x="457200" y="3749040"/>
-            <a:ext cx="5394960" cy="777240"/>
+            <a:off x="457200" y="4251960"/>
+            <a:ext cx="5394960" cy="566928"/>
           </a:xfrm>
           <a:prstGeom prst="roundRect">
             <a:avLst>
-              <a:gd name="adj" fmla="val 11765"/>
+              <a:gd name="adj" fmla="val 16129"/>
             </a:avLst>
           </a:prstGeom>
           <a:solidFill>
@@ -2620,14 +2714,14 @@
       </p:sp>
       <p:sp>
         <p:nvSpPr>
-          <p:cNvPr id="13" name="Goal text"/>
+          <p:cNvPr id="10" name="Rule text"/>
           <p:cNvSpPr txBox="1"/>
           <p:nvPr/>
         </p:nvSpPr>
         <p:spPr>
           <a:xfrm>
-            <a:off x="731520" y="3749040"/>
-            <a:ext cx="4846320" cy="777240"/>
+            <a:off x="685800" y="4251960"/>
+            <a:ext cx="4937760" cy="566928"/>
           </a:xfrm>
           <a:prstGeom prst="rect">
             <a:avLst/>
@@ -2643,25 +2737,14 @@
               <a:buNone/>
             </a:pPr>
             <a:r>
-              <a:rPr lang="en-US" sz="1600" b="1" dirty="0">
-                <a:solidFill>
-                  <a:srgbClr val="9EDFF7"/>
-                </a:solidFill>
-              </a:rPr>
-              <a:t>Goal: </a:t>
-            </a:r>
-            <a:pPr indent="0" marL="0">
-              <a:buNone/>
-            </a:pPr>
-            <a:r>
-              <a:rPr lang="en-US" sz="1600" dirty="0">
+              <a:rPr lang="en-US" sz="1400" b="1" dirty="0">
                 <a:solidFill>
                   <a:schemeClr val="bg1"/>
                 </a:solidFill>
               </a:rPr>
-              <a:t>an accurate wAPMT, fewer units falling, happier customers.</a:t>
-            </a:r>
-            <a:endParaRPr lang="en-US" sz="1600" dirty="0"/>
+              <a:t>Never force items back into a full bin.</a:t>
+            </a:r>
+            <a:endParaRPr lang="en-US" sz="1400" dirty="0"/>
           </a:p>
         </p:txBody>
       </p:sp>
@@ -2676,6 +2759,737 @@
 <file path=ppt/slides/slide11.xml><?xml version="1.0" encoding="utf-8"?>
 <p:sld xmlns:a="http://schemas.openxmlformats.org/drawingml/2006/main" xmlns:r="http://schemas.openxmlformats.org/officeDocument/2006/relationships" xmlns:p="http://schemas.openxmlformats.org/presentationml/2006/main">
   <p:cSld name="Slide 11">
+    <p:spTree>
+      <p:nvGrpSpPr>
+        <p:cNvPr id="1" name=""/>
+        <p:cNvGrpSpPr/>
+        <p:nvPr/>
+      </p:nvGrpSpPr>
+      <p:grpSpPr>
+        <a:xfrm>
+          <a:off x="0" y="0"/>
+          <a:ext cx="0" cy="0"/>
+          <a:chOff x="0" y="0"/>
+          <a:chExt cx="0" cy="0"/>
+        </a:xfrm>
+      </p:grpSpPr>
+      <p:sp>
+        <p:nvSpPr>
+          <p:cNvPr id="2" name="Text 0"/>
+          <p:cNvSpPr/>
+          <p:nvPr>
+            <p:ph idx="101" type="title" hasCustomPrompt="1"/>
+          </p:nvPr>
+        </p:nvSpPr>
+        <p:spPr>
+          <a:xfrm>
+            <a:off x="457200" y="640080"/>
+            <a:ext cx="5394960" cy="548640"/>
+          </a:xfrm>
+          <a:prstGeom prst="rect">
+            <a:avLst/>
+          </a:prstGeom>
+          <a:noFill/>
+          <a:ln/>
+        </p:spPr>
+        <p:txBody>
+          <a:bodyPr wrap="square" lIns="0" tIns="0" rIns="0" bIns="0" rtlCol="0" anchor="ctr"/>
+          <a:lstStyle/>
+          <a:p>
+            <a:pPr algn="l" indent="0" marL="0">
+              <a:buNone/>
+            </a:pPr>
+            <a:r>
+              <a:rPr lang="en-US" sz="2800" b="1" dirty="0">
+                <a:solidFill>
+                  <a:schemeClr val="tx1"/>
+                </a:solidFill>
+              </a:rPr>
+              <a:t>S: Stacking</a:t>
+            </a:r>
+            <a:endParaRPr lang="en-US" sz="2800" dirty="0"/>
+          </a:p>
+        </p:txBody>
+      </p:sp>
+      <p:sp>
+        <p:nvSpPr>
+          <p:cNvPr id="3" name="Wrong panel"/>
+          <p:cNvSpPr/>
+          <p:nvPr/>
+        </p:nvSpPr>
+        <p:spPr>
+          <a:xfrm>
+            <a:off x="457200" y="1325880"/>
+            <a:ext cx="2606040" cy="2788920"/>
+          </a:xfrm>
+          <a:prstGeom prst="roundRect">
+            <a:avLst>
+              <a:gd name="adj" fmla="val 3509"/>
+            </a:avLst>
+          </a:prstGeom>
+          <a:solidFill>
+            <a:schemeClr val="bg1"/>
+          </a:solidFill>
+          <a:ln w="38100">
+            <a:solidFill>
+              <a:srgbClr val="D64545"/>
+            </a:solidFill>
+            <a:prstDash val="solid"/>
+          </a:ln>
+        </p:spPr>
+      </p:sp>
+      <p:pic>
+        <p:nvPicPr>
+          <p:cNvPr id="4" name="Wrong picture" descr="Stacking: wrong example. Different items stacked on top of each other">    </p:cNvPr>
+          <p:cNvPicPr>
+            <a:picLocks noChangeAspect="1"/>
+          </p:cNvPicPr>
+          <p:nvPr/>
+        </p:nvPicPr>
+        <p:blipFill>
+          <a:blip r:embed="rId1"/>
+          <a:stretch>
+            <a:fillRect/>
+          </a:stretch>
+        </p:blipFill>
+        <p:spPr>
+          <a:xfrm>
+            <a:off x="623277" y="1417320"/>
+            <a:ext cx="2273886" cy="2103120"/>
+          </a:xfrm>
+          <a:prstGeom prst="rect">
+            <a:avLst/>
+          </a:prstGeom>
+        </p:spPr>
+      </p:pic>
+      <p:sp>
+        <p:nvSpPr>
+          <p:cNvPr id="5" name="Wrong caption"/>
+          <p:cNvSpPr txBox="1"/>
+          <p:nvPr/>
+        </p:nvSpPr>
+        <p:spPr>
+          <a:xfrm>
+            <a:off x="594360" y="3547872"/>
+            <a:ext cx="2331720" cy="502920"/>
+          </a:xfrm>
+          <a:prstGeom prst="rect">
+            <a:avLst/>
+          </a:prstGeom>
+          <a:noFill/>
+          <a:ln/>
+        </p:spPr>
+        <p:txBody>
+          <a:bodyPr wrap="square" lIns="0" tIns="0" rIns="0" bIns="0" rtlCol="0" anchor="ctr"/>
+          <a:lstStyle/>
+          <a:p>
+            <a:pPr algn="ctr" indent="0" marL="0">
+              <a:buNone/>
+            </a:pPr>
+            <a:r>
+              <a:rPr lang="en-US" sz="1300" b="1" dirty="0">
+                <a:solidFill>
+                  <a:schemeClr val="accent3"/>
+                </a:solidFill>
+              </a:rPr>
+              <a:t>WRONG: </a:t>
+            </a:r>
+            <a:pPr algn="ctr" indent="0" marL="0">
+              <a:buNone/>
+            </a:pPr>
+            <a:r>
+              <a:rPr lang="en-US" sz="1300" dirty="0">
+                <a:solidFill>
+                  <a:schemeClr val="tx1"/>
+                </a:solidFill>
+              </a:rPr>
+              <a:t>Different items stacked on top of each other</a:t>
+            </a:r>
+            <a:endParaRPr lang="en-US" sz="1300" dirty="0"/>
+          </a:p>
+        </p:txBody>
+      </p:sp>
+      <p:sp>
+        <p:nvSpPr>
+          <p:cNvPr id="6" name="Right panel"/>
+          <p:cNvSpPr/>
+          <p:nvPr/>
+        </p:nvSpPr>
+        <p:spPr>
+          <a:xfrm>
+            <a:off x="3246120" y="1325880"/>
+            <a:ext cx="2606040" cy="2788920"/>
+          </a:xfrm>
+          <a:prstGeom prst="roundRect">
+            <a:avLst>
+              <a:gd name="adj" fmla="val 3509"/>
+            </a:avLst>
+          </a:prstGeom>
+          <a:solidFill>
+            <a:schemeClr val="bg1"/>
+          </a:solidFill>
+          <a:ln w="38100">
+            <a:solidFill>
+              <a:srgbClr val="2E7D32"/>
+            </a:solidFill>
+            <a:prstDash val="solid"/>
+          </a:ln>
+        </p:spPr>
+      </p:sp>
+      <p:pic>
+        <p:nvPicPr>
+          <p:cNvPr id="7" name="Right picture" descr="Stacking: right example. Items stand side by side, below the bands">    </p:cNvPr>
+          <p:cNvPicPr>
+            <a:picLocks noChangeAspect="1"/>
+          </p:cNvPicPr>
+          <p:nvPr/>
+        </p:nvPicPr>
+        <p:blipFill>
+          <a:blip r:embed="rId2"/>
+          <a:stretch>
+            <a:fillRect/>
+          </a:stretch>
+        </p:blipFill>
+        <p:spPr>
+          <a:xfrm>
+            <a:off x="3430172" y="1417320"/>
+            <a:ext cx="2237935" cy="2103120"/>
+          </a:xfrm>
+          <a:prstGeom prst="rect">
+            <a:avLst/>
+          </a:prstGeom>
+        </p:spPr>
+      </p:pic>
+      <p:sp>
+        <p:nvSpPr>
+          <p:cNvPr id="8" name="Right caption"/>
+          <p:cNvSpPr txBox="1"/>
+          <p:nvPr/>
+        </p:nvSpPr>
+        <p:spPr>
+          <a:xfrm>
+            <a:off x="3383280" y="3547872"/>
+            <a:ext cx="2331720" cy="502920"/>
+          </a:xfrm>
+          <a:prstGeom prst="rect">
+            <a:avLst/>
+          </a:prstGeom>
+          <a:noFill/>
+          <a:ln/>
+        </p:spPr>
+        <p:txBody>
+          <a:bodyPr wrap="square" lIns="0" tIns="0" rIns="0" bIns="0" rtlCol="0" anchor="ctr"/>
+          <a:lstStyle/>
+          <a:p>
+            <a:pPr algn="ctr" indent="0" marL="0">
+              <a:buNone/>
+            </a:pPr>
+            <a:r>
+              <a:rPr lang="en-US" sz="1300" b="1" dirty="0">
+                <a:solidFill>
+                  <a:srgbClr val="2E7D32"/>
+                </a:solidFill>
+              </a:rPr>
+              <a:t>RIGHT: </a:t>
+            </a:r>
+            <a:pPr algn="ctr" indent="0" marL="0">
+              <a:buNone/>
+            </a:pPr>
+            <a:r>
+              <a:rPr lang="en-US" sz="1300" dirty="0">
+                <a:solidFill>
+                  <a:schemeClr val="tx1"/>
+                </a:solidFill>
+              </a:rPr>
+              <a:t>Items stand side by side, below the bands</a:t>
+            </a:r>
+            <a:endParaRPr lang="en-US" sz="1300" dirty="0"/>
+          </a:p>
+        </p:txBody>
+      </p:sp>
+      <p:sp>
+        <p:nvSpPr>
+          <p:cNvPr id="9" name="Rule card"/>
+          <p:cNvSpPr/>
+          <p:nvPr/>
+        </p:nvSpPr>
+        <p:spPr>
+          <a:xfrm>
+            <a:off x="457200" y="4251960"/>
+            <a:ext cx="5394960" cy="566928"/>
+          </a:xfrm>
+          <a:prstGeom prst="roundRect">
+            <a:avLst>
+              <a:gd name="adj" fmla="val 16129"/>
+            </a:avLst>
+          </a:prstGeom>
+          <a:solidFill>
+            <a:schemeClr val="tx2"/>
+          </a:solidFill>
+          <a:ln/>
+        </p:spPr>
+      </p:sp>
+      <p:sp>
+        <p:nvSpPr>
+          <p:cNvPr id="10" name="Rule text"/>
+          <p:cNvSpPr txBox="1"/>
+          <p:nvPr/>
+        </p:nvSpPr>
+        <p:spPr>
+          <a:xfrm>
+            <a:off x="685800" y="4251960"/>
+            <a:ext cx="4937760" cy="566928"/>
+          </a:xfrm>
+          <a:prstGeom prst="rect">
+            <a:avLst/>
+          </a:prstGeom>
+          <a:noFill/>
+          <a:ln/>
+        </p:spPr>
+        <p:txBody>
+          <a:bodyPr wrap="square" lIns="0" tIns="0" rIns="0" bIns="0" rtlCol="0" anchor="ctr"/>
+          <a:lstStyle/>
+          <a:p>
+            <a:pPr indent="0" marL="0">
+              <a:buNone/>
+            </a:pPr>
+            <a:r>
+              <a:rPr lang="en-US" sz="1400" b="1" dirty="0">
+                <a:solidFill>
+                  <a:schemeClr val="bg1"/>
+                </a:solidFill>
+              </a:rPr>
+              <a:t>Keep everything below the retention bands.</a:t>
+            </a:r>
+            <a:endParaRPr lang="en-US" sz="1400" dirty="0"/>
+          </a:p>
+        </p:txBody>
+      </p:sp>
+    </p:spTree>
+  </p:cSld>
+  <p:clrMapOvr>
+    <a:masterClrMapping/>
+  </p:clrMapOvr>
+</p:sld>
+</file>
+
+<file path=ppt/slides/slide12.xml><?xml version="1.0" encoding="utf-8"?>
+<p:sld xmlns:a="http://schemas.openxmlformats.org/drawingml/2006/main" xmlns:r="http://schemas.openxmlformats.org/officeDocument/2006/relationships" xmlns:p="http://schemas.openxmlformats.org/presentationml/2006/main">
+  <p:cSld name="Slide 12">
+    <p:spTree>
+      <p:nvGrpSpPr>
+        <p:cNvPr id="1" name=""/>
+        <p:cNvGrpSpPr/>
+        <p:nvPr/>
+      </p:nvGrpSpPr>
+      <p:grpSpPr>
+        <a:xfrm>
+          <a:off x="0" y="0"/>
+          <a:ext cx="0" cy="0"/>
+          <a:chOff x="0" y="0"/>
+          <a:chExt cx="0" cy="0"/>
+        </a:xfrm>
+      </p:grpSpPr>
+      <p:sp>
+        <p:nvSpPr>
+          <p:cNvPr id="2" name="Text 0"/>
+          <p:cNvSpPr/>
+          <p:nvPr>
+            <p:ph idx="101" type="title" hasCustomPrompt="1"/>
+          </p:nvPr>
+        </p:nvSpPr>
+        <p:spPr>
+          <a:xfrm>
+            <a:off x="457200" y="640080"/>
+            <a:ext cx="5394960" cy="548640"/>
+          </a:xfrm>
+          <a:prstGeom prst="rect">
+            <a:avLst/>
+          </a:prstGeom>
+          <a:noFill/>
+          <a:ln/>
+        </p:spPr>
+        <p:txBody>
+          <a:bodyPr wrap="square" lIns="0" tIns="0" rIns="0" bIns="0" rtlCol="0" anchor="ctr"/>
+          <a:lstStyle/>
+          <a:p>
+            <a:pPr algn="l" indent="0" marL="0">
+              <a:buNone/>
+            </a:pPr>
+            <a:r>
+              <a:rPr lang="en-US" sz="2800" b="1" dirty="0">
+                <a:solidFill>
+                  <a:schemeClr val="tx1"/>
+                </a:solidFill>
+              </a:rPr>
+              <a:t>Your pick checklist</a:t>
+            </a:r>
+            <a:endParaRPr lang="en-US" sz="2800" dirty="0"/>
+          </a:p>
+        </p:txBody>
+      </p:sp>
+      <p:sp>
+        <p:nvSpPr>
+          <p:cNvPr id="3" name="Recap circle 1"/>
+          <p:cNvSpPr/>
+          <p:nvPr/>
+        </p:nvSpPr>
+        <p:spPr>
+          <a:xfrm>
+            <a:off x="868680" y="1371600"/>
+            <a:ext cx="868680" cy="868680"/>
+          </a:xfrm>
+          <a:prstGeom prst="ellipse">
+            <a:avLst/>
+          </a:prstGeom>
+          <a:solidFill>
+            <a:schemeClr val="accent1"/>
+          </a:solidFill>
+          <a:ln/>
+        </p:spPr>
+      </p:sp>
+      <p:pic>
+        <p:nvPicPr>
+          <p:cNvPr id="4" name="Recap icon 1" descr="preencoded.png">    </p:cNvPr>
+          <p:cNvPicPr>
+            <a:picLocks noChangeAspect="1"/>
+          </p:cNvPicPr>
+          <p:nvPr/>
+        </p:nvPicPr>
+        <p:blipFill>
+          <a:blip r:embed="rId1"/>
+          <a:stretch>
+            <a:fillRect/>
+          </a:stretch>
+        </p:blipFill>
+        <p:spPr>
+          <a:xfrm>
+            <a:off x="1088136" y="1591056"/>
+            <a:ext cx="429768" cy="429768"/>
+          </a:xfrm>
+          <a:prstGeom prst="rect">
+            <a:avLst/>
+          </a:prstGeom>
+        </p:spPr>
+      </p:pic>
+      <p:sp>
+        <p:nvSpPr>
+          <p:cNvPr id="5" name="Recap text 1"/>
+          <p:cNvSpPr txBox="1"/>
+          <p:nvPr/>
+        </p:nvSpPr>
+        <p:spPr>
+          <a:xfrm>
+            <a:off x="457200" y="2423160"/>
+            <a:ext cx="1691640" cy="1097280"/>
+          </a:xfrm>
+          <a:prstGeom prst="rect">
+            <a:avLst/>
+          </a:prstGeom>
+          <a:noFill/>
+          <a:ln/>
+        </p:spPr>
+        <p:txBody>
+          <a:bodyPr wrap="square" lIns="0" tIns="0" rIns="0" bIns="0" rtlCol="0" anchor="t"/>
+          <a:lstStyle/>
+          <a:p>
+            <a:pPr algn="ctr" indent="0" marL="0">
+              <a:buNone/>
+            </a:pPr>
+            <a:r>
+              <a:rPr lang="en-US" sz="1300" dirty="0">
+                <a:solidFill>
+                  <a:schemeClr val="accent4"/>
+                </a:solidFill>
+              </a:rPr>
+              <a:t>Not picked yet</a:t>
+            </a:r>
+            <a:endParaRPr lang="en-US" sz="1300" dirty="0"/>
+          </a:p>
+          <a:p>
+            <a:pPr algn="ctr" indent="0" marL="0">
+              <a:buNone/>
+            </a:pPr>
+            <a:r>
+              <a:rPr lang="en-US" sz="1700" b="1" dirty="0">
+                <a:solidFill>
+                  <a:schemeClr val="tx1"/>
+                </a:solidFill>
+              </a:rPr>
+              <a:t>Amnesty</a:t>
+            </a:r>
+            <a:endParaRPr lang="en-US" sz="1300" dirty="0"/>
+          </a:p>
+        </p:txBody>
+      </p:sp>
+      <p:sp>
+        <p:nvSpPr>
+          <p:cNvPr id="6" name="Recap circle 2"/>
+          <p:cNvSpPr/>
+          <p:nvPr/>
+        </p:nvSpPr>
+        <p:spPr>
+          <a:xfrm>
+            <a:off x="2697480" y="1371600"/>
+            <a:ext cx="868680" cy="868680"/>
+          </a:xfrm>
+          <a:prstGeom prst="ellipse">
+            <a:avLst/>
+          </a:prstGeom>
+          <a:solidFill>
+            <a:schemeClr val="accent1"/>
+          </a:solidFill>
+          <a:ln/>
+        </p:spPr>
+      </p:sp>
+      <p:pic>
+        <p:nvPicPr>
+          <p:cNvPr id="7" name="Recap icon 2" descr="preencoded.png">    </p:cNvPr>
+          <p:cNvPicPr>
+            <a:picLocks noChangeAspect="1"/>
+          </p:cNvPicPr>
+          <p:nvPr/>
+        </p:nvPicPr>
+        <p:blipFill>
+          <a:blip r:embed="rId2"/>
+          <a:stretch>
+            <a:fillRect/>
+          </a:stretch>
+        </p:blipFill>
+        <p:spPr>
+          <a:xfrm>
+            <a:off x="2916936" y="1591056"/>
+            <a:ext cx="429768" cy="429768"/>
+          </a:xfrm>
+          <a:prstGeom prst="rect">
+            <a:avLst/>
+          </a:prstGeom>
+        </p:spPr>
+      </p:pic>
+      <p:sp>
+        <p:nvSpPr>
+          <p:cNvPr id="8" name="Recap text 2"/>
+          <p:cNvSpPr txBox="1"/>
+          <p:nvPr/>
+        </p:nvSpPr>
+        <p:spPr>
+          <a:xfrm>
+            <a:off x="2286000" y="2423160"/>
+            <a:ext cx="1691640" cy="1097280"/>
+          </a:xfrm>
+          <a:prstGeom prst="rect">
+            <a:avLst/>
+          </a:prstGeom>
+          <a:noFill/>
+          <a:ln/>
+        </p:spPr>
+        <p:txBody>
+          <a:bodyPr wrap="square" lIns="0" tIns="0" rIns="0" bIns="0" rtlCol="0" anchor="t"/>
+          <a:lstStyle/>
+          <a:p>
+            <a:pPr algn="ctr" indent="0" marL="0">
+              <a:buNone/>
+            </a:pPr>
+            <a:r>
+              <a:rPr lang="en-US" sz="1300" dirty="0">
+                <a:solidFill>
+                  <a:schemeClr val="accent4"/>
+                </a:solidFill>
+              </a:rPr>
+              <a:t>Already picked</a:t>
+            </a:r>
+            <a:endParaRPr lang="en-US" sz="1300" dirty="0"/>
+          </a:p>
+          <a:p>
+            <a:pPr algn="ctr" indent="0" marL="0">
+              <a:buNone/>
+            </a:pPr>
+            <a:r>
+              <a:rPr lang="en-US" sz="1700" b="1" dirty="0">
+                <a:solidFill>
+                  <a:schemeClr val="tx1"/>
+                </a:solidFill>
+              </a:rPr>
+              <a:t>Outbound problem solve</a:t>
+            </a:r>
+            <a:endParaRPr lang="en-US" sz="1300" dirty="0"/>
+          </a:p>
+        </p:txBody>
+      </p:sp>
+      <p:sp>
+        <p:nvSpPr>
+          <p:cNvPr id="9" name="Recap circle 3"/>
+          <p:cNvSpPr/>
+          <p:nvPr/>
+        </p:nvSpPr>
+        <p:spPr>
+          <a:xfrm>
+            <a:off x="4526280" y="1371600"/>
+            <a:ext cx="868680" cy="868680"/>
+          </a:xfrm>
+          <a:prstGeom prst="ellipse">
+            <a:avLst/>
+          </a:prstGeom>
+          <a:solidFill>
+            <a:schemeClr val="accent1"/>
+          </a:solidFill>
+          <a:ln/>
+        </p:spPr>
+      </p:sp>
+      <p:pic>
+        <p:nvPicPr>
+          <p:cNvPr id="10" name="Recap icon 3" descr="preencoded.png">    </p:cNvPr>
+          <p:cNvPicPr>
+            <a:picLocks noChangeAspect="1"/>
+          </p:cNvPicPr>
+          <p:nvPr/>
+        </p:nvPicPr>
+        <p:blipFill>
+          <a:blip r:embed="rId3"/>
+          <a:stretch>
+            <a:fillRect/>
+          </a:stretch>
+        </p:blipFill>
+        <p:spPr>
+          <a:xfrm>
+            <a:off x="4745736" y="1591056"/>
+            <a:ext cx="429768" cy="429768"/>
+          </a:xfrm>
+          <a:prstGeom prst="rect">
+            <a:avLst/>
+          </a:prstGeom>
+        </p:spPr>
+      </p:pic>
+      <p:sp>
+        <p:nvSpPr>
+          <p:cNvPr id="11" name="Recap text 3"/>
+          <p:cNvSpPr txBox="1"/>
+          <p:nvPr/>
+        </p:nvSpPr>
+        <p:spPr>
+          <a:xfrm>
+            <a:off x="4114800" y="2423160"/>
+            <a:ext cx="1691640" cy="1097280"/>
+          </a:xfrm>
+          <a:prstGeom prst="rect">
+            <a:avLst/>
+          </a:prstGeom>
+          <a:noFill/>
+          <a:ln/>
+        </p:spPr>
+        <p:txBody>
+          <a:bodyPr wrap="square" lIns="0" tIns="0" rIns="0" bIns="0" rtlCol="0" anchor="t"/>
+          <a:lstStyle/>
+          <a:p>
+            <a:pPr algn="ctr" indent="0" marL="0">
+              <a:buNone/>
+            </a:pPr>
+            <a:r>
+              <a:rPr lang="en-US" sz="1300" dirty="0">
+                <a:solidFill>
+                  <a:schemeClr val="accent4"/>
+                </a:solidFill>
+              </a:rPr>
+              <a:t>Every bin you touch</a:t>
+            </a:r>
+            <a:endParaRPr lang="en-US" sz="1300" dirty="0"/>
+          </a:p>
+          <a:p>
+            <a:pPr algn="ctr" indent="0" marL="0">
+              <a:buNone/>
+            </a:pPr>
+            <a:r>
+              <a:rPr lang="en-US" sz="1700" b="1" dirty="0">
+                <a:solidFill>
+                  <a:schemeClr val="tx1"/>
+                </a:solidFill>
+              </a:rPr>
+              <a:t>One at a time, fix as you go</a:t>
+            </a:r>
+            <a:endParaRPr lang="en-US" sz="1300" dirty="0"/>
+          </a:p>
+        </p:txBody>
+      </p:sp>
+      <p:sp>
+        <p:nvSpPr>
+          <p:cNvPr id="12" name="Goal card"/>
+          <p:cNvSpPr/>
+          <p:nvPr/>
+        </p:nvSpPr>
+        <p:spPr>
+          <a:xfrm>
+            <a:off x="457200" y="3749040"/>
+            <a:ext cx="5394960" cy="777240"/>
+          </a:xfrm>
+          <a:prstGeom prst="roundRect">
+            <a:avLst>
+              <a:gd name="adj" fmla="val 11765"/>
+            </a:avLst>
+          </a:prstGeom>
+          <a:solidFill>
+            <a:schemeClr val="tx2"/>
+          </a:solidFill>
+          <a:ln/>
+        </p:spPr>
+      </p:sp>
+      <p:sp>
+        <p:nvSpPr>
+          <p:cNvPr id="13" name="Goal text"/>
+          <p:cNvSpPr txBox="1"/>
+          <p:nvPr/>
+        </p:nvSpPr>
+        <p:spPr>
+          <a:xfrm>
+            <a:off x="731520" y="3749040"/>
+            <a:ext cx="4846320" cy="777240"/>
+          </a:xfrm>
+          <a:prstGeom prst="rect">
+            <a:avLst/>
+          </a:prstGeom>
+          <a:noFill/>
+          <a:ln/>
+        </p:spPr>
+        <p:txBody>
+          <a:bodyPr wrap="square" lIns="0" tIns="0" rIns="0" bIns="0" rtlCol="0" anchor="ctr"/>
+          <a:lstStyle/>
+          <a:p>
+            <a:pPr indent="0" marL="0">
+              <a:buNone/>
+            </a:pPr>
+            <a:r>
+              <a:rPr lang="en-US" sz="1600" b="1" dirty="0">
+                <a:solidFill>
+                  <a:srgbClr val="9EDFF7"/>
+                </a:solidFill>
+              </a:rPr>
+              <a:t>Goal: </a:t>
+            </a:r>
+            <a:pPr indent="0" marL="0">
+              <a:buNone/>
+            </a:pPr>
+            <a:r>
+              <a:rPr lang="en-US" sz="1600" dirty="0">
+                <a:solidFill>
+                  <a:schemeClr val="bg1"/>
+                </a:solidFill>
+              </a:rPr>
+              <a:t>an accurate wAPMT, fewer units falling, happier customers.</a:t>
+            </a:r>
+            <a:endParaRPr lang="en-US" sz="1600" dirty="0"/>
+          </a:p>
+        </p:txBody>
+      </p:sp>
+    </p:spTree>
+  </p:cSld>
+  <p:clrMapOvr>
+    <a:masterClrMapping/>
+  </p:clrMapOvr>
+</p:sld>
+</file>
+
+<file path=ppt/slides/slide13.xml><?xml version="1.0" encoding="utf-8"?>
+<p:sld xmlns:a="http://schemas.openxmlformats.org/drawingml/2006/main" xmlns:r="http://schemas.openxmlformats.org/officeDocument/2006/relationships" xmlns:p="http://schemas.openxmlformats.org/presentationml/2006/main">
+  <p:cSld name="Slide 13">
     <p:spTree>
       <p:nvGrpSpPr>
         <p:cNvPr id="1" name=""/>
@@ -5177,7 +5991,7 @@
                   <a:schemeClr val="tx1"/>
                 </a:solidFill>
               </a:rPr>
-              <a:t>Fix as you go: inside the bin</a:t>
+              <a:t>O: No overhang</a:t>
             </a:r>
             <a:endParaRPr lang="en-US" sz="2800" dirty="0"/>
           </a:p>
@@ -5185,14 +5999,14 @@
       </p:sp>
       <p:sp>
         <p:nvSpPr>
-          <p:cNvPr id="3" name="Rule card 1"/>
+          <p:cNvPr id="3" name="Wrong panel"/>
           <p:cNvSpPr/>
           <p:nvPr/>
         </p:nvSpPr>
         <p:spPr>
           <a:xfrm>
             <a:off x="457200" y="1325880"/>
-            <a:ext cx="2606040" cy="3246120"/>
+            <a:ext cx="2606040" cy="2788920"/>
           </a:xfrm>
           <a:prstGeom prst="roundRect">
             <a:avLst>
@@ -5202,107 +6016,17 @@
           <a:solidFill>
             <a:schemeClr val="bg1"/>
           </a:solidFill>
-          <a:ln/>
-        </p:spPr>
-      </p:sp>
-      <p:sp>
-        <p:nvSpPr>
-          <p:cNvPr id="4" name="Rule badge 1"/>
-          <p:cNvSpPr/>
-          <p:nvPr/>
-        </p:nvSpPr>
-        <p:spPr>
-          <a:xfrm>
-            <a:off x="640080" y="1490472"/>
-            <a:ext cx="502920" cy="502920"/>
-          </a:xfrm>
-          <a:prstGeom prst="ellipse">
-            <a:avLst/>
-          </a:prstGeom>
-          <a:solidFill>
-            <a:schemeClr val="tx2"/>
-          </a:solidFill>
-          <a:ln/>
-        </p:spPr>
-      </p:sp>
-      <p:sp>
-        <p:nvSpPr>
-          <p:cNvPr id="5" name="Rule letter 1"/>
-          <p:cNvSpPr txBox="1"/>
-          <p:nvPr/>
-        </p:nvSpPr>
-        <p:spPr>
-          <a:xfrm>
-            <a:off x="640080" y="1490472"/>
-            <a:ext cx="502920" cy="502920"/>
-          </a:xfrm>
-          <a:prstGeom prst="rect">
-            <a:avLst/>
-          </a:prstGeom>
-          <a:noFill/>
-          <a:ln/>
-        </p:spPr>
-        <p:txBody>
-          <a:bodyPr wrap="square" lIns="0" tIns="0" rIns="0" bIns="0" rtlCol="0" anchor="ctr"/>
-          <a:lstStyle/>
-          <a:p>
-            <a:pPr algn="ctr" indent="0" marL="0">
-              <a:buNone/>
-            </a:pPr>
-            <a:r>
-              <a:rPr lang="en-US" sz="2200" b="1" dirty="0">
-                <a:solidFill>
-                  <a:schemeClr val="accent1"/>
-                </a:solidFill>
-                <a:latin typeface="Arial" pitchFamily="34" charset="0"/>
-                <a:ea typeface="Arial" pitchFamily="34" charset="-122"/>
-                <a:cs typeface="Arial" pitchFamily="34" charset="-120"/>
-              </a:rPr>
-              <a:t>O</a:t>
-            </a:r>
-            <a:endParaRPr lang="en-US" sz="2200" dirty="0"/>
-          </a:p>
-        </p:txBody>
-      </p:sp>
-      <p:sp>
-        <p:nvSpPr>
-          <p:cNvPr id="6" name="Rule name 1"/>
-          <p:cNvSpPr txBox="1"/>
-          <p:nvPr/>
-        </p:nvSpPr>
-        <p:spPr>
-          <a:xfrm>
-            <a:off x="1280160" y="1490472"/>
-            <a:ext cx="1645920" cy="502920"/>
-          </a:xfrm>
-          <a:prstGeom prst="rect">
-            <a:avLst/>
-          </a:prstGeom>
-          <a:noFill/>
-          <a:ln/>
-        </p:spPr>
-        <p:txBody>
-          <a:bodyPr wrap="square" lIns="0" tIns="0" rIns="0" bIns="0" rtlCol="0" anchor="ctr"/>
-          <a:lstStyle/>
-          <a:p>
-            <a:pPr indent="0" marL="0">
-              <a:buNone/>
-            </a:pPr>
-            <a:r>
-              <a:rPr lang="en-US" sz="1700" b="1" dirty="0">
-                <a:solidFill>
-                  <a:schemeClr val="tx1"/>
-                </a:solidFill>
-              </a:rPr>
-              <a:t>No overhang</a:t>
-            </a:r>
-            <a:endParaRPr lang="en-US" sz="1700" dirty="0"/>
-          </a:p>
-        </p:txBody>
+          <a:ln w="38100">
+            <a:solidFill>
+              <a:srgbClr val="D64545"/>
+            </a:solidFill>
+            <a:prstDash val="solid"/>
+          </a:ln>
+        </p:spPr>
       </p:sp>
       <p:pic>
         <p:nvPicPr>
-          <p:cNvPr id="7" name="Rule picture 1" descr="No overhang: wrong and right example">    </p:cNvPr>
+          <p:cNvPr id="4" name="Wrong picture" descr="No overhang: wrong example. The box sticks out past the bin edge">    </p:cNvPr>
           <p:cNvPicPr>
             <a:picLocks noChangeAspect="1"/>
           </p:cNvPicPr>
@@ -5316,8 +6040,8 @@
         </p:blipFill>
         <p:spPr>
           <a:xfrm>
-            <a:off x="640080" y="2143936"/>
-            <a:ext cx="2240280" cy="924208"/>
+            <a:off x="700128" y="1417320"/>
+            <a:ext cx="2120184" cy="2103120"/>
           </a:xfrm>
           <a:prstGeom prst="rect">
             <a:avLst/>
@@ -5326,14 +6050,14 @@
       </p:pic>
       <p:sp>
         <p:nvSpPr>
-          <p:cNvPr id="8" name="Rule detail 1"/>
+          <p:cNvPr id="5" name="Wrong caption"/>
           <p:cNvSpPr txBox="1"/>
           <p:nvPr/>
         </p:nvSpPr>
         <p:spPr>
           <a:xfrm>
-            <a:off x="640080" y="3246120"/>
-            <a:ext cx="2286000" cy="1234440"/>
+            <a:off x="594360" y="3547872"/>
+            <a:ext cx="2331720" cy="502920"/>
           </a:xfrm>
           <a:prstGeom prst="rect">
             <a:avLst/>
@@ -5342,38 +6066,45 @@
           <a:ln/>
         </p:spPr>
         <p:txBody>
-          <a:bodyPr wrap="square" lIns="0" tIns="0" rIns="0" bIns="0" rtlCol="0" anchor="t"/>
-          <a:lstStyle/>
-          <a:p>
-            <a:pPr marL="342900" indent="-342900">
-              <a:spcAft>
-                <a:spcPts val="400"/>
-              </a:spcAft>
-              <a:buSzPct val="100000"/>
-              <a:buChar char="•"/>
-            </a:pPr>
-            <a:r>
-              <a:rPr lang="en-US" sz="1400" dirty="0">
-                <a:solidFill>
-                  <a:schemeClr val="accent4"/>
-                </a:solidFill>
-              </a:rPr>
-              <a:t>Push anything sticking out fully back inside</a:t>
-            </a:r>
-            <a:endParaRPr lang="en-US" sz="1400" dirty="0"/>
-          </a:p>
-        </p:txBody>
-      </p:sp>
-      <p:sp>
-        <p:nvSpPr>
-          <p:cNvPr id="9" name="Rule card 2"/>
+          <a:bodyPr wrap="square" lIns="0" tIns="0" rIns="0" bIns="0" rtlCol="0" anchor="ctr"/>
+          <a:lstStyle/>
+          <a:p>
+            <a:pPr algn="ctr" indent="0" marL="0">
+              <a:buNone/>
+            </a:pPr>
+            <a:r>
+              <a:rPr lang="en-US" sz="1300" b="1" dirty="0">
+                <a:solidFill>
+                  <a:schemeClr val="accent3"/>
+                </a:solidFill>
+              </a:rPr>
+              <a:t>WRONG: </a:t>
+            </a:r>
+            <a:pPr algn="ctr" indent="0" marL="0">
+              <a:buNone/>
+            </a:pPr>
+            <a:r>
+              <a:rPr lang="en-US" sz="1300" dirty="0">
+                <a:solidFill>
+                  <a:schemeClr val="tx1"/>
+                </a:solidFill>
+              </a:rPr>
+              <a:t>The box sticks out past the bin edge</a:t>
+            </a:r>
+            <a:endParaRPr lang="en-US" sz="1300" dirty="0"/>
+          </a:p>
+        </p:txBody>
+      </p:sp>
+      <p:sp>
+        <p:nvSpPr>
+          <p:cNvPr id="6" name="Right panel"/>
           <p:cNvSpPr/>
           <p:nvPr/>
         </p:nvSpPr>
         <p:spPr>
           <a:xfrm>
             <a:off x="3246120" y="1325880"/>
-            <a:ext cx="2606040" cy="3246120"/>
+            <a:ext cx="2606040" cy="2788920"/>
           </a:xfrm>
           <a:prstGeom prst="roundRect">
             <a:avLst>
@@ -5383,107 +6114,17 @@
           <a:solidFill>
             <a:schemeClr val="bg1"/>
           </a:solidFill>
-          <a:ln/>
-        </p:spPr>
-      </p:sp>
-      <p:sp>
-        <p:nvSpPr>
-          <p:cNvPr id="10" name="Rule badge 2"/>
-          <p:cNvSpPr/>
-          <p:nvPr/>
-        </p:nvSpPr>
-        <p:spPr>
-          <a:xfrm>
-            <a:off x="3429000" y="1490472"/>
-            <a:ext cx="502920" cy="502920"/>
-          </a:xfrm>
-          <a:prstGeom prst="ellipse">
-            <a:avLst/>
-          </a:prstGeom>
-          <a:solidFill>
-            <a:schemeClr val="tx2"/>
-          </a:solidFill>
-          <a:ln/>
-        </p:spPr>
-      </p:sp>
-      <p:sp>
-        <p:nvSpPr>
-          <p:cNvPr id="11" name="Rule letter 2"/>
-          <p:cNvSpPr txBox="1"/>
-          <p:nvPr/>
-        </p:nvSpPr>
-        <p:spPr>
-          <a:xfrm>
-            <a:off x="3429000" y="1490472"/>
-            <a:ext cx="502920" cy="502920"/>
-          </a:xfrm>
-          <a:prstGeom prst="rect">
-            <a:avLst/>
-          </a:prstGeom>
-          <a:noFill/>
-          <a:ln/>
-        </p:spPr>
-        <p:txBody>
-          <a:bodyPr wrap="square" lIns="0" tIns="0" rIns="0" bIns="0" rtlCol="0" anchor="ctr"/>
-          <a:lstStyle/>
-          <a:p>
-            <a:pPr algn="ctr" indent="0" marL="0">
-              <a:buNone/>
-            </a:pPr>
-            <a:r>
-              <a:rPr lang="en-US" sz="2200" b="1" dirty="0">
-                <a:solidFill>
-                  <a:schemeClr val="accent1"/>
-                </a:solidFill>
-                <a:latin typeface="Arial" pitchFamily="34" charset="0"/>
-                <a:ea typeface="Arial" pitchFamily="34" charset="-122"/>
-                <a:cs typeface="Arial" pitchFamily="34" charset="-120"/>
-              </a:rPr>
-              <a:t>B</a:t>
-            </a:r>
-            <a:endParaRPr lang="en-US" sz="2200" dirty="0"/>
-          </a:p>
-        </p:txBody>
-      </p:sp>
-      <p:sp>
-        <p:nvSpPr>
-          <p:cNvPr id="12" name="Rule name 2"/>
-          <p:cNvSpPr txBox="1"/>
-          <p:nvPr/>
-        </p:nvSpPr>
-        <p:spPr>
-          <a:xfrm>
-            <a:off x="4069080" y="1490472"/>
-            <a:ext cx="1645920" cy="502920"/>
-          </a:xfrm>
-          <a:prstGeom prst="rect">
-            <a:avLst/>
-          </a:prstGeom>
-          <a:noFill/>
-          <a:ln/>
-        </p:spPr>
-        <p:txBody>
-          <a:bodyPr wrap="square" lIns="0" tIns="0" rIns="0" bIns="0" rtlCol="0" anchor="ctr"/>
-          <a:lstStyle/>
-          <a:p>
-            <a:pPr indent="0" marL="0">
-              <a:buNone/>
-            </a:pPr>
-            <a:r>
-              <a:rPr lang="en-US" sz="1700" b="1" dirty="0">
-                <a:solidFill>
-                  <a:schemeClr val="tx1"/>
-                </a:solidFill>
-              </a:rPr>
-              <a:t>Blocking</a:t>
-            </a:r>
-            <a:endParaRPr lang="en-US" sz="1700" dirty="0"/>
-          </a:p>
-        </p:txBody>
+          <a:ln w="38100">
+            <a:solidFill>
+              <a:srgbClr val="2E7D32"/>
+            </a:solidFill>
+            <a:prstDash val="solid"/>
+          </a:ln>
+        </p:spPr>
       </p:sp>
       <p:pic>
         <p:nvPicPr>
-          <p:cNvPr id="13" name="Rule picture 2" descr="Blocking: wrong and right example">    </p:cNvPr>
+          <p:cNvPr id="7" name="Right picture" descr="No overhang: right example. Everything sits fully inside the bin">    </p:cNvPr>
           <p:cNvPicPr>
             <a:picLocks noChangeAspect="1"/>
           </p:cNvPicPr>
@@ -5497,8 +6138,8 @@
         </p:blipFill>
         <p:spPr>
           <a:xfrm>
-            <a:off x="3429000" y="2136542"/>
-            <a:ext cx="2240280" cy="938995"/>
+            <a:off x="3521332" y="1417320"/>
+            <a:ext cx="2055616" cy="2103120"/>
           </a:xfrm>
           <a:prstGeom prst="rect">
             <a:avLst/>
@@ -5507,14 +6148,14 @@
       </p:pic>
       <p:sp>
         <p:nvSpPr>
-          <p:cNvPr id="14" name="Rule detail 2"/>
+          <p:cNvPr id="8" name="Right caption"/>
           <p:cNvSpPr txBox="1"/>
           <p:nvPr/>
         </p:nvSpPr>
         <p:spPr>
           <a:xfrm>
-            <a:off x="3429000" y="3246120"/>
-            <a:ext cx="2286000" cy="1234440"/>
+            <a:off x="3383280" y="3547872"/>
+            <a:ext cx="2331720" cy="502920"/>
           </a:xfrm>
           <a:prstGeom prst="rect">
             <a:avLst/>
@@ -5523,41 +6164,88 @@
           <a:ln/>
         </p:spPr>
         <p:txBody>
-          <a:bodyPr wrap="square" lIns="0" tIns="0" rIns="0" bIns="0" rtlCol="0" anchor="t"/>
-          <a:lstStyle/>
-          <a:p>
-            <a:pPr marL="342900" indent="-342900">
-              <a:spcAft>
-                <a:spcPts val="400"/>
-              </a:spcAft>
-              <a:buSzPct val="100000"/>
-              <a:buChar char="•"/>
-            </a:pPr>
-            <a:r>
-              <a:rPr lang="en-US" sz="1400" dirty="0">
-                <a:solidFill>
-                  <a:schemeClr val="accent4"/>
-                </a:solidFill>
-              </a:rPr>
-              <a:t>Don't leave small items hidden behind big ones</a:t>
-            </a:r>
-            <a:endParaRPr lang="en-US" sz="1400" dirty="0"/>
-          </a:p>
-          <a:p>
-            <a:pPr marL="342900" indent="-342900">
-              <a:spcAft>
-                <a:spcPts val="400"/>
-              </a:spcAft>
-              <a:buSzPct val="100000"/>
-              <a:buChar char="•"/>
-            </a:pPr>
-            <a:r>
-              <a:rPr lang="en-US" sz="1400" dirty="0">
-                <a:solidFill>
-                  <a:schemeClr val="accent4"/>
-                </a:solidFill>
-              </a:rPr>
-              <a:t>Stand flat items upright</a:t>
+          <a:bodyPr wrap="square" lIns="0" tIns="0" rIns="0" bIns="0" rtlCol="0" anchor="ctr"/>
+          <a:lstStyle/>
+          <a:p>
+            <a:pPr algn="ctr" indent="0" marL="0">
+              <a:buNone/>
+            </a:pPr>
+            <a:r>
+              <a:rPr lang="en-US" sz="1300" b="1" dirty="0">
+                <a:solidFill>
+                  <a:srgbClr val="2E7D32"/>
+                </a:solidFill>
+              </a:rPr>
+              <a:t>RIGHT: </a:t>
+            </a:r>
+            <a:pPr algn="ctr" indent="0" marL="0">
+              <a:buNone/>
+            </a:pPr>
+            <a:r>
+              <a:rPr lang="en-US" sz="1300" dirty="0">
+                <a:solidFill>
+                  <a:schemeClr val="tx1"/>
+                </a:solidFill>
+              </a:rPr>
+              <a:t>Everything sits fully inside the bin</a:t>
+            </a:r>
+            <a:endParaRPr lang="en-US" sz="1300" dirty="0"/>
+          </a:p>
+        </p:txBody>
+      </p:sp>
+      <p:sp>
+        <p:nvSpPr>
+          <p:cNvPr id="9" name="Rule card"/>
+          <p:cNvSpPr/>
+          <p:nvPr/>
+        </p:nvSpPr>
+        <p:spPr>
+          <a:xfrm>
+            <a:off x="457200" y="4251960"/>
+            <a:ext cx="5394960" cy="566928"/>
+          </a:xfrm>
+          <a:prstGeom prst="roundRect">
+            <a:avLst>
+              <a:gd name="adj" fmla="val 16129"/>
+            </a:avLst>
+          </a:prstGeom>
+          <a:solidFill>
+            <a:schemeClr val="tx2"/>
+          </a:solidFill>
+          <a:ln/>
+        </p:spPr>
+      </p:sp>
+      <p:sp>
+        <p:nvSpPr>
+          <p:cNvPr id="10" name="Rule text"/>
+          <p:cNvSpPr txBox="1"/>
+          <p:nvPr/>
+        </p:nvSpPr>
+        <p:spPr>
+          <a:xfrm>
+            <a:off x="685800" y="4251960"/>
+            <a:ext cx="4937760" cy="566928"/>
+          </a:xfrm>
+          <a:prstGeom prst="rect">
+            <a:avLst/>
+          </a:prstGeom>
+          <a:noFill/>
+          <a:ln/>
+        </p:spPr>
+        <p:txBody>
+          <a:bodyPr wrap="square" lIns="0" tIns="0" rIns="0" bIns="0" rtlCol="0" anchor="ctr"/>
+          <a:lstStyle/>
+          <a:p>
+            <a:pPr indent="0" marL="0">
+              <a:buNone/>
+            </a:pPr>
+            <a:r>
+              <a:rPr lang="en-US" sz="1400" b="1" dirty="0">
+                <a:solidFill>
+                  <a:schemeClr val="bg1"/>
+                </a:solidFill>
+              </a:rPr>
+              <a:t>Spot something sticking out? Push it fully back inside the bin.</a:t>
             </a:r>
             <a:endParaRPr lang="en-US" sz="1400" dirty="0"/>
           </a:p>
@@ -5620,7 +6308,7 @@
                   <a:schemeClr val="tx1"/>
                 </a:solidFill>
               </a:rPr>
-              <a:t>Fix as you go: keep it tidy</a:t>
+              <a:t>B: Blocking</a:t>
             </a:r>
             <a:endParaRPr lang="en-US" sz="2800" dirty="0"/>
           </a:p>
@@ -5628,14 +6316,14 @@
       </p:sp>
       <p:sp>
         <p:nvSpPr>
-          <p:cNvPr id="3" name="Rule card 1"/>
+          <p:cNvPr id="3" name="Wrong panel"/>
           <p:cNvSpPr/>
           <p:nvPr/>
         </p:nvSpPr>
         <p:spPr>
           <a:xfrm>
             <a:off x="457200" y="1325880"/>
-            <a:ext cx="2606040" cy="3246120"/>
+            <a:ext cx="2606040" cy="2788920"/>
           </a:xfrm>
           <a:prstGeom prst="roundRect">
             <a:avLst>
@@ -5645,107 +6333,17 @@
           <a:solidFill>
             <a:schemeClr val="bg1"/>
           </a:solidFill>
-          <a:ln/>
-        </p:spPr>
-      </p:sp>
-      <p:sp>
-        <p:nvSpPr>
-          <p:cNvPr id="4" name="Rule badge 1"/>
-          <p:cNvSpPr/>
-          <p:nvPr/>
-        </p:nvSpPr>
-        <p:spPr>
-          <a:xfrm>
-            <a:off x="640080" y="1490472"/>
-            <a:ext cx="502920" cy="502920"/>
-          </a:xfrm>
-          <a:prstGeom prst="ellipse">
-            <a:avLst/>
-          </a:prstGeom>
-          <a:solidFill>
-            <a:schemeClr val="tx2"/>
-          </a:solidFill>
-          <a:ln/>
-        </p:spPr>
-      </p:sp>
-      <p:sp>
-        <p:nvSpPr>
-          <p:cNvPr id="5" name="Rule letter 1"/>
-          <p:cNvSpPr txBox="1"/>
-          <p:nvPr/>
-        </p:nvSpPr>
-        <p:spPr>
-          <a:xfrm>
-            <a:off x="640080" y="1490472"/>
-            <a:ext cx="502920" cy="502920"/>
-          </a:xfrm>
-          <a:prstGeom prst="rect">
-            <a:avLst/>
-          </a:prstGeom>
-          <a:noFill/>
-          <a:ln/>
-        </p:spPr>
-        <p:txBody>
-          <a:bodyPr wrap="square" lIns="0" tIns="0" rIns="0" bIns="0" rtlCol="0" anchor="ctr"/>
-          <a:lstStyle/>
-          <a:p>
-            <a:pPr algn="ctr" indent="0" marL="0">
-              <a:buNone/>
-            </a:pPr>
-            <a:r>
-              <a:rPr lang="en-US" sz="2200" b="1" dirty="0">
-                <a:solidFill>
-                  <a:schemeClr val="accent1"/>
-                </a:solidFill>
-                <a:latin typeface="Arial" pitchFamily="34" charset="0"/>
-                <a:ea typeface="Arial" pitchFamily="34" charset="-122"/>
-                <a:cs typeface="Arial" pitchFamily="34" charset="-120"/>
-              </a:rPr>
-              <a:t>O</a:t>
-            </a:r>
-            <a:endParaRPr lang="en-US" sz="2200" dirty="0"/>
-          </a:p>
-        </p:txBody>
-      </p:sp>
-      <p:sp>
-        <p:nvSpPr>
-          <p:cNvPr id="6" name="Rule name 1"/>
-          <p:cNvSpPr txBox="1"/>
-          <p:nvPr/>
-        </p:nvSpPr>
-        <p:spPr>
-          <a:xfrm>
-            <a:off x="1280160" y="1490472"/>
-            <a:ext cx="1645920" cy="502920"/>
-          </a:xfrm>
-          <a:prstGeom prst="rect">
-            <a:avLst/>
-          </a:prstGeom>
-          <a:noFill/>
-          <a:ln/>
-        </p:spPr>
-        <p:txBody>
-          <a:bodyPr wrap="square" lIns="0" tIns="0" rIns="0" bIns="0" rtlCol="0" anchor="ctr"/>
-          <a:lstStyle/>
-          <a:p>
-            <a:pPr indent="0" marL="0">
-              <a:buNone/>
-            </a:pPr>
-            <a:r>
-              <a:rPr lang="en-US" sz="1700" b="1" dirty="0">
-                <a:solidFill>
-                  <a:schemeClr val="tx1"/>
-                </a:solidFill>
-              </a:rPr>
-              <a:t>Overstuffing</a:t>
-            </a:r>
-            <a:endParaRPr lang="en-US" sz="1700" dirty="0"/>
-          </a:p>
-        </p:txBody>
+          <a:ln w="38100">
+            <a:solidFill>
+              <a:srgbClr val="D64545"/>
+            </a:solidFill>
+            <a:prstDash val="solid"/>
+          </a:ln>
+        </p:spPr>
       </p:sp>
       <p:pic>
         <p:nvPicPr>
-          <p:cNvPr id="7" name="Rule picture 1" descr="Overstuffing: wrong and right example">    </p:cNvPr>
+          <p:cNvPr id="4" name="Wrong picture" descr="Blocking: wrong example. A flat item in front hides the items behind it">    </p:cNvPr>
           <p:cNvPicPr>
             <a:picLocks noChangeAspect="1"/>
           </p:cNvPicPr>
@@ -5759,8 +6357,8 @@
         </p:blipFill>
         <p:spPr>
           <a:xfrm>
-            <a:off x="640080" y="2162420"/>
-            <a:ext cx="2240280" cy="887240"/>
+            <a:off x="706557" y="1417320"/>
+            <a:ext cx="2107326" cy="2103120"/>
           </a:xfrm>
           <a:prstGeom prst="rect">
             <a:avLst/>
@@ -5769,14 +6367,14 @@
       </p:pic>
       <p:sp>
         <p:nvSpPr>
-          <p:cNvPr id="8" name="Rule detail 1"/>
+          <p:cNvPr id="5" name="Wrong caption"/>
           <p:cNvSpPr txBox="1"/>
           <p:nvPr/>
         </p:nvSpPr>
         <p:spPr>
           <a:xfrm>
-            <a:off x="640080" y="3246120"/>
-            <a:ext cx="2286000" cy="1234440"/>
+            <a:off x="594360" y="3547872"/>
+            <a:ext cx="2331720" cy="502920"/>
           </a:xfrm>
           <a:prstGeom prst="rect">
             <a:avLst/>
@@ -5785,38 +6383,45 @@
           <a:ln/>
         </p:spPr>
         <p:txBody>
-          <a:bodyPr wrap="square" lIns="0" tIns="0" rIns="0" bIns="0" rtlCol="0" anchor="t"/>
-          <a:lstStyle/>
-          <a:p>
-            <a:pPr marL="342900" indent="-342900">
-              <a:spcAft>
-                <a:spcPts val="400"/>
-              </a:spcAft>
-              <a:buSzPct val="100000"/>
-              <a:buChar char="•"/>
-            </a:pPr>
-            <a:r>
-              <a:rPr lang="en-US" sz="1400" dirty="0">
-                <a:solidFill>
-                  <a:schemeClr val="accent4"/>
-                </a:solidFill>
-              </a:rPr>
-              <a:t>Never force items back into a full bin</a:t>
-            </a:r>
-            <a:endParaRPr lang="en-US" sz="1400" dirty="0"/>
-          </a:p>
-        </p:txBody>
-      </p:sp>
-      <p:sp>
-        <p:nvSpPr>
-          <p:cNvPr id="9" name="Rule card 2"/>
+          <a:bodyPr wrap="square" lIns="0" tIns="0" rIns="0" bIns="0" rtlCol="0" anchor="ctr"/>
+          <a:lstStyle/>
+          <a:p>
+            <a:pPr algn="ctr" indent="0" marL="0">
+              <a:buNone/>
+            </a:pPr>
+            <a:r>
+              <a:rPr lang="en-US" sz="1300" b="1" dirty="0">
+                <a:solidFill>
+                  <a:schemeClr val="accent3"/>
+                </a:solidFill>
+              </a:rPr>
+              <a:t>WRONG: </a:t>
+            </a:r>
+            <a:pPr algn="ctr" indent="0" marL="0">
+              <a:buNone/>
+            </a:pPr>
+            <a:r>
+              <a:rPr lang="en-US" sz="1300" dirty="0">
+                <a:solidFill>
+                  <a:schemeClr val="tx1"/>
+                </a:solidFill>
+              </a:rPr>
+              <a:t>A flat item in front hides the items behind it</a:t>
+            </a:r>
+            <a:endParaRPr lang="en-US" sz="1300" dirty="0"/>
+          </a:p>
+        </p:txBody>
+      </p:sp>
+      <p:sp>
+        <p:nvSpPr>
+          <p:cNvPr id="6" name="Right panel"/>
           <p:cNvSpPr/>
           <p:nvPr/>
         </p:nvSpPr>
         <p:spPr>
           <a:xfrm>
             <a:off x="3246120" y="1325880"/>
-            <a:ext cx="2606040" cy="3246120"/>
+            <a:ext cx="2606040" cy="2788920"/>
           </a:xfrm>
           <a:prstGeom prst="roundRect">
             <a:avLst>
@@ -5826,107 +6431,17 @@
           <a:solidFill>
             <a:schemeClr val="bg1"/>
           </a:solidFill>
-          <a:ln/>
-        </p:spPr>
-      </p:sp>
-      <p:sp>
-        <p:nvSpPr>
-          <p:cNvPr id="10" name="Rule badge 2"/>
-          <p:cNvSpPr/>
-          <p:nvPr/>
-        </p:nvSpPr>
-        <p:spPr>
-          <a:xfrm>
-            <a:off x="3429000" y="1490472"/>
-            <a:ext cx="502920" cy="502920"/>
-          </a:xfrm>
-          <a:prstGeom prst="ellipse">
-            <a:avLst/>
-          </a:prstGeom>
-          <a:solidFill>
-            <a:schemeClr val="tx2"/>
-          </a:solidFill>
-          <a:ln/>
-        </p:spPr>
-      </p:sp>
-      <p:sp>
-        <p:nvSpPr>
-          <p:cNvPr id="11" name="Rule letter 2"/>
-          <p:cNvSpPr txBox="1"/>
-          <p:nvPr/>
-        </p:nvSpPr>
-        <p:spPr>
-          <a:xfrm>
-            <a:off x="3429000" y="1490472"/>
-            <a:ext cx="502920" cy="502920"/>
-          </a:xfrm>
-          <a:prstGeom prst="rect">
-            <a:avLst/>
-          </a:prstGeom>
-          <a:noFill/>
-          <a:ln/>
-        </p:spPr>
-        <p:txBody>
-          <a:bodyPr wrap="square" lIns="0" tIns="0" rIns="0" bIns="0" rtlCol="0" anchor="ctr"/>
-          <a:lstStyle/>
-          <a:p>
-            <a:pPr algn="ctr" indent="0" marL="0">
-              <a:buNone/>
-            </a:pPr>
-            <a:r>
-              <a:rPr lang="en-US" sz="2200" b="1" dirty="0">
-                <a:solidFill>
-                  <a:schemeClr val="accent1"/>
-                </a:solidFill>
-                <a:latin typeface="Arial" pitchFamily="34" charset="0"/>
-                <a:ea typeface="Arial" pitchFamily="34" charset="-122"/>
-                <a:cs typeface="Arial" pitchFamily="34" charset="-120"/>
-              </a:rPr>
-              <a:t>S</a:t>
-            </a:r>
-            <a:endParaRPr lang="en-US" sz="2200" dirty="0"/>
-          </a:p>
-        </p:txBody>
-      </p:sp>
-      <p:sp>
-        <p:nvSpPr>
-          <p:cNvPr id="12" name="Rule name 2"/>
-          <p:cNvSpPr txBox="1"/>
-          <p:nvPr/>
-        </p:nvSpPr>
-        <p:spPr>
-          <a:xfrm>
-            <a:off x="4069080" y="1490472"/>
-            <a:ext cx="1645920" cy="502920"/>
-          </a:xfrm>
-          <a:prstGeom prst="rect">
-            <a:avLst/>
-          </a:prstGeom>
-          <a:noFill/>
-          <a:ln/>
-        </p:spPr>
-        <p:txBody>
-          <a:bodyPr wrap="square" lIns="0" tIns="0" rIns="0" bIns="0" rtlCol="0" anchor="ctr"/>
-          <a:lstStyle/>
-          <a:p>
-            <a:pPr indent="0" marL="0">
-              <a:buNone/>
-            </a:pPr>
-            <a:r>
-              <a:rPr lang="en-US" sz="1700" b="1" dirty="0">
-                <a:solidFill>
-                  <a:schemeClr val="tx1"/>
-                </a:solidFill>
-              </a:rPr>
-              <a:t>Stacking</a:t>
-            </a:r>
-            <a:endParaRPr lang="en-US" sz="1700" dirty="0"/>
-          </a:p>
-        </p:txBody>
+          <a:ln w="38100">
+            <a:solidFill>
+              <a:srgbClr val="2E7D32"/>
+            </a:solidFill>
+            <a:prstDash val="solid"/>
+          </a:ln>
+        </p:spPr>
       </p:sp>
       <p:pic>
         <p:nvPicPr>
-          <p:cNvPr id="13" name="Rule picture 2" descr="Stacking: wrong and right example">    </p:cNvPr>
+          <p:cNvPr id="7" name="Right picture" descr="Blocking: right example. Every item is visible from the front">    </p:cNvPr>
           <p:cNvPicPr>
             <a:picLocks noChangeAspect="1"/>
           </p:cNvPicPr>
@@ -5940,8 +6455,8 @@
         </p:blipFill>
         <p:spPr>
           <a:xfrm>
-            <a:off x="3429000" y="2173511"/>
-            <a:ext cx="2240280" cy="865059"/>
+            <a:off x="3489168" y="1417320"/>
+            <a:ext cx="2119945" cy="2103120"/>
           </a:xfrm>
           <a:prstGeom prst="rect">
             <a:avLst/>
@@ -5950,14 +6465,14 @@
       </p:pic>
       <p:sp>
         <p:nvSpPr>
-          <p:cNvPr id="14" name="Rule detail 2"/>
+          <p:cNvPr id="8" name="Right caption"/>
           <p:cNvSpPr txBox="1"/>
           <p:nvPr/>
         </p:nvSpPr>
         <p:spPr>
           <a:xfrm>
-            <a:off x="3429000" y="3246120"/>
-            <a:ext cx="2286000" cy="1234440"/>
+            <a:off x="3383280" y="3547872"/>
+            <a:ext cx="2331720" cy="502920"/>
           </a:xfrm>
           <a:prstGeom prst="rect">
             <a:avLst/>
@@ -5966,23 +6481,88 @@
           <a:ln/>
         </p:spPr>
         <p:txBody>
-          <a:bodyPr wrap="square" lIns="0" tIns="0" rIns="0" bIns="0" rtlCol="0" anchor="t"/>
-          <a:lstStyle/>
-          <a:p>
-            <a:pPr marL="342900" indent="-342900">
-              <a:spcAft>
-                <a:spcPts val="400"/>
-              </a:spcAft>
-              <a:buSzPct val="100000"/>
-              <a:buChar char="•"/>
-            </a:pPr>
-            <a:r>
-              <a:rPr lang="en-US" sz="1400" dirty="0">
-                <a:solidFill>
-                  <a:schemeClr val="accent4"/>
-                </a:solidFill>
-              </a:rPr>
-              <a:t>Keep everything below the retention bands</a:t>
+          <a:bodyPr wrap="square" lIns="0" tIns="0" rIns="0" bIns="0" rtlCol="0" anchor="ctr"/>
+          <a:lstStyle/>
+          <a:p>
+            <a:pPr algn="ctr" indent="0" marL="0">
+              <a:buNone/>
+            </a:pPr>
+            <a:r>
+              <a:rPr lang="en-US" sz="1300" b="1" dirty="0">
+                <a:solidFill>
+                  <a:srgbClr val="2E7D32"/>
+                </a:solidFill>
+              </a:rPr>
+              <a:t>RIGHT: </a:t>
+            </a:r>
+            <a:pPr algn="ctr" indent="0" marL="0">
+              <a:buNone/>
+            </a:pPr>
+            <a:r>
+              <a:rPr lang="en-US" sz="1300" dirty="0">
+                <a:solidFill>
+                  <a:schemeClr val="tx1"/>
+                </a:solidFill>
+              </a:rPr>
+              <a:t>Every item is visible from the front</a:t>
+            </a:r>
+            <a:endParaRPr lang="en-US" sz="1300" dirty="0"/>
+          </a:p>
+        </p:txBody>
+      </p:sp>
+      <p:sp>
+        <p:nvSpPr>
+          <p:cNvPr id="9" name="Rule card"/>
+          <p:cNvSpPr/>
+          <p:nvPr/>
+        </p:nvSpPr>
+        <p:spPr>
+          <a:xfrm>
+            <a:off x="457200" y="4251960"/>
+            <a:ext cx="5394960" cy="566928"/>
+          </a:xfrm>
+          <a:prstGeom prst="roundRect">
+            <a:avLst>
+              <a:gd name="adj" fmla="val 16129"/>
+            </a:avLst>
+          </a:prstGeom>
+          <a:solidFill>
+            <a:schemeClr val="tx2"/>
+          </a:solidFill>
+          <a:ln/>
+        </p:spPr>
+      </p:sp>
+      <p:sp>
+        <p:nvSpPr>
+          <p:cNvPr id="10" name="Rule text"/>
+          <p:cNvSpPr txBox="1"/>
+          <p:nvPr/>
+        </p:nvSpPr>
+        <p:spPr>
+          <a:xfrm>
+            <a:off x="685800" y="4251960"/>
+            <a:ext cx="4937760" cy="566928"/>
+          </a:xfrm>
+          <a:prstGeom prst="rect">
+            <a:avLst/>
+          </a:prstGeom>
+          <a:noFill/>
+          <a:ln/>
+        </p:spPr>
+        <p:txBody>
+          <a:bodyPr wrap="square" lIns="0" tIns="0" rIns="0" bIns="0" rtlCol="0" anchor="ctr"/>
+          <a:lstStyle/>
+          <a:p>
+            <a:pPr indent="0" marL="0">
+              <a:buNone/>
+            </a:pPr>
+            <a:r>
+              <a:rPr lang="en-US" sz="1400" b="1" dirty="0">
+                <a:solidFill>
+                  <a:schemeClr val="bg1"/>
+                </a:solidFill>
+              </a:rPr>
+              <a:t>Don't leave small items hidden behind big ones; stand flat items upright.</a:t>
             </a:r>
             <a:endParaRPr lang="en-US" sz="1400" dirty="0"/>
           </a:p>

</xml_diff>

<commit_message>
Stow deck: inbound problem solve distinction; pick deck keeps outbound
Co-Authored-By: Claude Opus 5.5 <noreply@anthropic.com>
Claude-Session: https://claude.ai/code/session_01Cr6d8mb1XkHfhN1yyjHEjG
</commit_message>
<xml_diff>
--- a/APMT_Coaching_Pick_to_Rebin.pptx
+++ b/APMT_Coaching_Pick_to_Rebin.pptx
@@ -119,7 +119,7 @@
   <p:extLst>
     <p:ext uri="{521415D9-36F7-43E2-AB2F-B90AF26B5E84}">
       <p14:sectionLst xmlns:p14="http://schemas.microsoft.com/office/powerpoint/2010/main">
-        <p14:section name="Intro" id="{05f6309b-c00d-fb4a-16dc-74631591e648}">
+        <p14:section name="Intro" id="{013203fd-3566-701b-5f6f-20fdeecb1130}">
           <p14:sldIdLst>
             <p14:sldId id="256"/>
             <p14:sldId id="257"/>
@@ -128,7 +128,7 @@
             <p14:sldId id="260"/>
           </p14:sldIdLst>
         </p14:section>
-        <p14:section name="Bin etiquette" id="{c577cd64-002e-99d8-3f1c-d3e9567e4b98}">
+        <p14:section name="Bin etiquette" id="{e4d62312-ec72-4fdc-adca-640d1d1c9bae}">
           <p14:sldIdLst>
             <p14:sldId id="261"/>
             <p14:sldId id="262"/>
@@ -138,7 +138,7 @@
             <p14:sldId id="266"/>
           </p14:sldIdLst>
         </p14:section>
-        <p14:section name="Wrap-up" id="{6d1f7199-341d-8dbd-bb1f-39f562932228}">
+        <p14:section name="Wrap-up" id="{c19ad297-86e7-9c5b-fdac-50c42d62097e}">
           <p14:sldIdLst>
             <p14:sldId id="267"/>
             <p14:sldId id="268"/>
@@ -4621,7 +4621,7 @@
                   <a:schemeClr val="tx1"/>
                 </a:solidFill>
               </a:rPr>
-              <a:t>Not picked yet</a:t>
+              <a:t>Stowed, not picked yet</a:t>
             </a:r>
             <a:endParaRPr lang="en-US" sz="1800" dirty="0"/>
           </a:p>

</xml_diff>